<commit_message>
Refresh CFP pitch deck — positive title, sourced stats, restructured slides
- Slide 1: reframe title from "your clients are missing" to "your clients
  are asking for" — positive framing, mirrors slide 2's questions setup
- Slide 3: replace unsourced 73% with 92% purpose stat (Edward Jones / Age
  Wave) and add real-source per-pillar stats from portal articles (Fidelity
  2024, Hill & Turiano 2014, Caring.com 2024)
- Slide 4: replace 3-column "what it's not / is / why" grid with a
  hero-paragraph + Harvard Study pull-quote layout to vary cadence
- Slide 11: drop "Charge More," reorder to Differentiate / Discover / Retain
- Slide 12: restore per-client/mo line under each tier so headline price
  reads clearly as roster-inclusive, not per-client
- Build: rename cfp-pitch-deck-build.js to .cjs (repo is "type": "module")
  and add pptxgenjs as devDependency

Co-Authored-By: Claude Opus 4.7 (1M context) <noreply@anthropic.com>
</commit_message>
<xml_diff>
--- a/decks/RetireMore-CFP-Pitch-Deck.pptx
+++ b/decks/RetireMore-CFP-Pitch-Deck.pptx
@@ -2329,7 +2329,7 @@
                 <a:ea typeface="Georgia" pitchFamily="34" charset="-122"/>
                 <a:cs typeface="Georgia" pitchFamily="34" charset="-120"/>
               </a:rPr>
-              <a:t>missing</a:t>
+              <a:t>asking for</a:t>
             </a:r>
             <a:pPr indent="0" marL="0">
               <a:buNone/>
@@ -3840,7 +3840,7 @@
         <p:spPr>
           <a:xfrm>
             <a:off x="548640" y="2103120"/>
-            <a:ext cx="2697480" cy="3749040"/>
+            <a:ext cx="3593592" cy="3749040"/>
           </a:xfrm>
           <a:prstGeom prst="rect">
             <a:avLst/>
@@ -3872,7 +3872,7 @@
         <p:spPr>
           <a:xfrm>
             <a:off x="548640" y="2103120"/>
-            <a:ext cx="2697480" cy="109728"/>
+            <a:ext cx="3593592" cy="109728"/>
           </a:xfrm>
           <a:prstGeom prst="rect">
             <a:avLst/>
@@ -3931,7 +3931,7 @@
         <p:spPr>
           <a:xfrm>
             <a:off x="822960" y="3657600"/>
-            <a:ext cx="2148840" cy="548640"/>
+            <a:ext cx="3044952" cy="548640"/>
           </a:xfrm>
           <a:prstGeom prst="rect">
             <a:avLst/>
@@ -3993,7 +3993,7 @@
         <p:spPr>
           <a:xfrm>
             <a:off x="822960" y="4434840"/>
-            <a:ext cx="2148840" cy="1280160"/>
+            <a:ext cx="3044952" cy="1280160"/>
           </a:xfrm>
           <a:prstGeom prst="rect">
             <a:avLst/>
@@ -4031,8 +4031,8 @@
         </p:nvSpPr>
         <p:spPr>
           <a:xfrm>
-            <a:off x="3364992" y="2103120"/>
-            <a:ext cx="2697480" cy="3749040"/>
+            <a:off x="4288536" y="2103120"/>
+            <a:ext cx="3593592" cy="3749040"/>
           </a:xfrm>
           <a:prstGeom prst="rect">
             <a:avLst/>
@@ -4063,14 +4063,14 @@
         </p:nvSpPr>
         <p:spPr>
           <a:xfrm>
-            <a:off x="3364992" y="2103120"/>
-            <a:ext cx="2697480" cy="109728"/>
+            <a:off x="4288536" y="2103120"/>
+            <a:ext cx="3593592" cy="109728"/>
           </a:xfrm>
           <a:prstGeom prst="rect">
             <a:avLst/>
           </a:prstGeom>
           <a:solidFill>
-            <a:srgbClr val="C8973A"/>
+            <a:srgbClr val="EA580C"/>
           </a:solidFill>
           <a:ln/>
         </p:spPr>
@@ -4083,7 +4083,7 @@
         </p:nvSpPr>
         <p:spPr>
           <a:xfrm>
-            <a:off x="3639312" y="2468880"/>
+            <a:off x="4562856" y="2468880"/>
             <a:ext cx="1828800" cy="1097280"/>
           </a:xfrm>
           <a:prstGeom prst="rect">
@@ -4102,7 +4102,7 @@
             <a:r>
               <a:rPr lang="en-US" sz="6400" b="1" dirty="0">
                 <a:solidFill>
-                  <a:srgbClr val="C8973A"/>
+                  <a:srgbClr val="EA580C"/>
                 </a:solidFill>
                 <a:latin typeface="Georgia" pitchFamily="34" charset="0"/>
                 <a:ea typeface="Georgia" pitchFamily="34" charset="-122"/>
@@ -4122,8 +4122,8 @@
         </p:nvSpPr>
         <p:spPr>
           <a:xfrm>
-            <a:off x="3639312" y="3657600"/>
-            <a:ext cx="2148840" cy="548640"/>
+            <a:off x="4562856" y="3657600"/>
+            <a:ext cx="3044952" cy="548640"/>
           </a:xfrm>
           <a:prstGeom prst="rect">
             <a:avLst/>
@@ -4147,7 +4147,7 @@
                 <a:ea typeface="Georgia" pitchFamily="34" charset="-122"/>
                 <a:cs typeface="Georgia" pitchFamily="34" charset="-120"/>
               </a:rPr>
-              <a:t>Retain</a:t>
+              <a:t>Discover</a:t>
             </a:r>
             <a:endParaRPr lang="en-US" sz="2200" dirty="0"/>
           </a:p>
@@ -4161,7 +4161,7 @@
         </p:nvSpPr>
         <p:spPr>
           <a:xfrm>
-            <a:off x="3639312" y="4251960"/>
+            <a:off x="4562856" y="4251960"/>
             <a:ext cx="731520" cy="0"/>
           </a:xfrm>
           <a:prstGeom prst="line">
@@ -4170,7 +4170,7 @@
           <a:noFill/>
           <a:ln w="25400">
             <a:solidFill>
-              <a:srgbClr val="C8973A"/>
+              <a:srgbClr val="EA580C"/>
             </a:solidFill>
             <a:prstDash val="solid"/>
           </a:ln>
@@ -4184,8 +4184,8 @@
         </p:nvSpPr>
         <p:spPr>
           <a:xfrm>
-            <a:off x="3639312" y="4434840"/>
-            <a:ext cx="2148840" cy="1280160"/>
+            <a:off x="4562856" y="4434840"/>
+            <a:ext cx="3044952" cy="1280160"/>
           </a:xfrm>
           <a:prstGeom prst="rect">
             <a:avLst/>
@@ -4209,7 +4209,7 @@
                 <a:ea typeface="Calibri" pitchFamily="34" charset="-122"/>
                 <a:cs typeface="Calibri" pitchFamily="34" charset="-120"/>
               </a:rPr>
-              <a:t>Clients engage with your brand between meetings. Higher retention. Lower churn. Stickier referrals.</a:t>
+              <a:t>The Find a Planner directory drives qualified prospects to you — fiduciary-aligned, fee-free, full-picture.</a:t>
             </a:r>
             <a:endParaRPr lang="en-US" sz="1200" dirty="0"/>
           </a:p>
@@ -4223,8 +4223,8 @@
         </p:nvSpPr>
         <p:spPr>
           <a:xfrm>
-            <a:off x="6181344" y="2103120"/>
-            <a:ext cx="2697480" cy="3749040"/>
+            <a:off x="8028432" y="2103120"/>
+            <a:ext cx="3593592" cy="3749040"/>
           </a:xfrm>
           <a:prstGeom prst="rect">
             <a:avLst/>
@@ -4255,14 +4255,14 @@
         </p:nvSpPr>
         <p:spPr>
           <a:xfrm>
-            <a:off x="6181344" y="2103120"/>
-            <a:ext cx="2697480" cy="109728"/>
+            <a:off x="8028432" y="2103120"/>
+            <a:ext cx="3593592" cy="109728"/>
           </a:xfrm>
           <a:prstGeom prst="rect">
             <a:avLst/>
           </a:prstGeom>
           <a:solidFill>
-            <a:srgbClr val="EA580C"/>
+            <a:srgbClr val="C8973A"/>
           </a:solidFill>
           <a:ln/>
         </p:spPr>
@@ -4275,7 +4275,7 @@
         </p:nvSpPr>
         <p:spPr>
           <a:xfrm>
-            <a:off x="6455664" y="2468880"/>
+            <a:off x="8302752" y="2468880"/>
             <a:ext cx="1828800" cy="1097280"/>
           </a:xfrm>
           <a:prstGeom prst="rect">
@@ -4294,7 +4294,7 @@
             <a:r>
               <a:rPr lang="en-US" sz="6400" b="1" dirty="0">
                 <a:solidFill>
-                  <a:srgbClr val="EA580C"/>
+                  <a:srgbClr val="C8973A"/>
                 </a:solidFill>
                 <a:latin typeface="Georgia" pitchFamily="34" charset="0"/>
                 <a:ea typeface="Georgia" pitchFamily="34" charset="-122"/>
@@ -4314,8 +4314,8 @@
         </p:nvSpPr>
         <p:spPr>
           <a:xfrm>
-            <a:off x="6455664" y="3657600"/>
-            <a:ext cx="2148840" cy="548640"/>
+            <a:off x="8302752" y="3657600"/>
+            <a:ext cx="3044952" cy="548640"/>
           </a:xfrm>
           <a:prstGeom prst="rect">
             <a:avLst/>
@@ -4339,7 +4339,7 @@
                 <a:ea typeface="Georgia" pitchFamily="34" charset="-122"/>
                 <a:cs typeface="Georgia" pitchFamily="34" charset="-120"/>
               </a:rPr>
-              <a:t>Discover</a:t>
+              <a:t>Retain</a:t>
             </a:r>
             <a:endParaRPr lang="en-US" sz="2200" dirty="0"/>
           </a:p>
@@ -4353,7 +4353,7 @@
         </p:nvSpPr>
         <p:spPr>
           <a:xfrm>
-            <a:off x="6455664" y="4251960"/>
+            <a:off x="8302752" y="4251960"/>
             <a:ext cx="731520" cy="0"/>
           </a:xfrm>
           <a:prstGeom prst="line">
@@ -4362,7 +4362,7 @@
           <a:noFill/>
           <a:ln w="25400">
             <a:solidFill>
-              <a:srgbClr val="EA580C"/>
+              <a:srgbClr val="C8973A"/>
             </a:solidFill>
             <a:prstDash val="solid"/>
           </a:ln>
@@ -4376,8 +4376,8 @@
         </p:nvSpPr>
         <p:spPr>
           <a:xfrm>
-            <a:off x="6455664" y="4434840"/>
-            <a:ext cx="2148840" cy="1280160"/>
+            <a:off x="8302752" y="4434840"/>
+            <a:ext cx="3044952" cy="1280160"/>
           </a:xfrm>
           <a:prstGeom prst="rect">
             <a:avLst/>
@@ -4401,7 +4401,7 @@
                 <a:ea typeface="Calibri" pitchFamily="34" charset="-122"/>
                 <a:cs typeface="Calibri" pitchFamily="34" charset="-120"/>
               </a:rPr>
-              <a:t>The Find a Planner directory drives qualified prospects to you — fiduciary-aligned, fee-free, full-picture.</a:t>
+              <a:t>Clients engage with your brand between meetings. Higher retention. Lower churn. Stickier referrals.</a:t>
             </a:r>
             <a:endParaRPr lang="en-US" sz="1200" dirty="0"/>
           </a:p>
@@ -4409,289 +4409,97 @@
       </p:sp>
       <p:sp>
         <p:nvSpPr>
-          <p:cNvPr id="22" name="Shape 20"/>
-          <p:cNvSpPr/>
-          <p:nvPr/>
-        </p:nvSpPr>
-        <p:spPr>
-          <a:xfrm>
-            <a:off x="8997696" y="2103120"/>
-            <a:ext cx="2697480" cy="3749040"/>
-          </a:xfrm>
-          <a:prstGeom prst="rect">
-            <a:avLst/>
-          </a:prstGeom>
-          <a:solidFill>
-            <a:srgbClr val="FFFFFF"/>
-          </a:solidFill>
+          <p:cNvPr id="22" name="Text 20"/>
+          <p:cNvSpPr/>
+          <p:nvPr/>
+        </p:nvSpPr>
+        <p:spPr>
+          <a:xfrm>
+            <a:off x="548640" y="6035040"/>
+            <a:ext cx="10972800" cy="274320"/>
+          </a:xfrm>
+          <a:prstGeom prst="rect">
+            <a:avLst/>
+          </a:prstGeom>
+          <a:noFill/>
+          <a:ln/>
+        </p:spPr>
+        <p:txBody>
+          <a:bodyPr wrap="square" lIns="0" tIns="0" rIns="0" bIns="0" rtlCol="0" anchor="ctr"/>
+          <a:lstStyle/>
+          <a:p>
+            <a:pPr algn="ctr" indent="0" marL="0">
+              <a:buNone/>
+            </a:pPr>
+            <a:r>
+              <a:rPr lang="en-US" sz="1400" i="1" dirty="0">
+                <a:solidFill>
+                  <a:srgbClr val="6B5E62"/>
+                </a:solidFill>
+                <a:latin typeface="Calibri" pitchFamily="34" charset="0"/>
+                <a:ea typeface="Calibri" pitchFamily="34" charset="-122"/>
+                <a:cs typeface="Calibri" pitchFamily="34" charset="-120"/>
+              </a:rPr>
+              <a:t>You're not adding a tool. You're adding a </a:t>
+            </a:r>
+            <a:pPr algn="ctr" indent="0" marL="0">
+              <a:buNone/>
+            </a:pPr>
+            <a:r>
+              <a:rPr lang="en-US" sz="1400" b="1" i="1" dirty="0">
+                <a:solidFill>
+                  <a:srgbClr val="2A354A"/>
+                </a:solidFill>
+                <a:latin typeface="Calibri" pitchFamily="34" charset="0"/>
+                <a:ea typeface="Calibri" pitchFamily="34" charset="-122"/>
+                <a:cs typeface="Calibri" pitchFamily="34" charset="-120"/>
+              </a:rPr>
+              <a:t>category of service</a:t>
+            </a:r>
+            <a:pPr algn="ctr" indent="0" marL="0">
+              <a:buNone/>
+            </a:pPr>
+            <a:r>
+              <a:rPr lang="en-US" sz="1400" i="1" dirty="0">
+                <a:solidFill>
+                  <a:srgbClr val="6B5E62"/>
+                </a:solidFill>
+                <a:latin typeface="Calibri" pitchFamily="34" charset="0"/>
+                <a:ea typeface="Calibri" pitchFamily="34" charset="-122"/>
+                <a:cs typeface="Calibri" pitchFamily="34" charset="-120"/>
+              </a:rPr>
+              <a:t> that nobody else in your zip code offers.</a:t>
+            </a:r>
+            <a:endParaRPr lang="en-US" sz="1400" dirty="0"/>
+          </a:p>
+        </p:txBody>
+      </p:sp>
+      <p:sp>
+        <p:nvSpPr>
+          <p:cNvPr id="23" name="Shape 21"/>
+          <p:cNvSpPr/>
+          <p:nvPr/>
+        </p:nvSpPr>
+        <p:spPr>
+          <a:xfrm>
+            <a:off x="548640" y="6446520"/>
+            <a:ext cx="11091672" cy="0"/>
+          </a:xfrm>
+          <a:prstGeom prst="line">
+            <a:avLst/>
+          </a:prstGeom>
+          <a:noFill/>
           <a:ln w="9525">
             <a:solidFill>
               <a:srgbClr val="E5E7EB"/>
             </a:solidFill>
             <a:prstDash val="solid"/>
           </a:ln>
-          <a:effectLst>
-            <a:outerShdw sx="100000" sy="100000" kx="0" ky="0" algn="bl" rotWithShape="0" blurRad="101600" dist="25400" dir="5400000">
-              <a:srgbClr val="000000">
-                <a:alpha val="7000"/>
-              </a:srgbClr>
-            </a:outerShdw>
-          </a:effectLst>
-        </p:spPr>
-      </p:sp>
-      <p:sp>
-        <p:nvSpPr>
-          <p:cNvPr id="23" name="Shape 21"/>
-          <p:cNvSpPr/>
-          <p:nvPr/>
-        </p:nvSpPr>
-        <p:spPr>
-          <a:xfrm>
-            <a:off x="8997696" y="2103120"/>
-            <a:ext cx="2697480" cy="109728"/>
-          </a:xfrm>
-          <a:prstGeom prst="rect">
-            <a:avLst/>
-          </a:prstGeom>
-          <a:solidFill>
-            <a:srgbClr val="059669"/>
-          </a:solidFill>
-          <a:ln/>
         </p:spPr>
       </p:sp>
       <p:sp>
         <p:nvSpPr>
           <p:cNvPr id="24" name="Text 22"/>
-          <p:cNvSpPr/>
-          <p:nvPr/>
-        </p:nvSpPr>
-        <p:spPr>
-          <a:xfrm>
-            <a:off x="9272016" y="2468880"/>
-            <a:ext cx="1828800" cy="1097280"/>
-          </a:xfrm>
-          <a:prstGeom prst="rect">
-            <a:avLst/>
-          </a:prstGeom>
-          <a:noFill/>
-          <a:ln/>
-        </p:spPr>
-        <p:txBody>
-          <a:bodyPr wrap="square" lIns="0" tIns="0" rIns="0" bIns="0" rtlCol="0" anchor="ctr"/>
-          <a:lstStyle/>
-          <a:p>
-            <a:pPr indent="0" marL="0">
-              <a:buNone/>
-            </a:pPr>
-            <a:r>
-              <a:rPr lang="en-US" sz="6400" b="1" dirty="0">
-                <a:solidFill>
-                  <a:srgbClr val="059669"/>
-                </a:solidFill>
-                <a:latin typeface="Georgia" pitchFamily="34" charset="0"/>
-                <a:ea typeface="Georgia" pitchFamily="34" charset="-122"/>
-                <a:cs typeface="Georgia" pitchFamily="34" charset="-120"/>
-              </a:rPr>
-              <a:t>04</a:t>
-            </a:r>
-            <a:endParaRPr lang="en-US" sz="6400" dirty="0"/>
-          </a:p>
-        </p:txBody>
-      </p:sp>
-      <p:sp>
-        <p:nvSpPr>
-          <p:cNvPr id="25" name="Text 23"/>
-          <p:cNvSpPr/>
-          <p:nvPr/>
-        </p:nvSpPr>
-        <p:spPr>
-          <a:xfrm>
-            <a:off x="9272016" y="3657600"/>
-            <a:ext cx="2148840" cy="548640"/>
-          </a:xfrm>
-          <a:prstGeom prst="rect">
-            <a:avLst/>
-          </a:prstGeom>
-          <a:noFill/>
-          <a:ln/>
-        </p:spPr>
-        <p:txBody>
-          <a:bodyPr wrap="square" lIns="0" tIns="0" rIns="0" bIns="0" rtlCol="0" anchor="ctr"/>
-          <a:lstStyle/>
-          <a:p>
-            <a:pPr indent="0" marL="0">
-              <a:buNone/>
-            </a:pPr>
-            <a:r>
-              <a:rPr lang="en-US" sz="2200" b="1" dirty="0">
-                <a:solidFill>
-                  <a:srgbClr val="2A354A"/>
-                </a:solidFill>
-                <a:latin typeface="Georgia" pitchFamily="34" charset="0"/>
-                <a:ea typeface="Georgia" pitchFamily="34" charset="-122"/>
-                <a:cs typeface="Georgia" pitchFamily="34" charset="-120"/>
-              </a:rPr>
-              <a:t>Charge More</a:t>
-            </a:r>
-            <a:endParaRPr lang="en-US" sz="2200" dirty="0"/>
-          </a:p>
-        </p:txBody>
-      </p:sp>
-      <p:sp>
-        <p:nvSpPr>
-          <p:cNvPr id="26" name="Shape 24"/>
-          <p:cNvSpPr/>
-          <p:nvPr/>
-        </p:nvSpPr>
-        <p:spPr>
-          <a:xfrm>
-            <a:off x="9272016" y="4251960"/>
-            <a:ext cx="731520" cy="0"/>
-          </a:xfrm>
-          <a:prstGeom prst="line">
-            <a:avLst/>
-          </a:prstGeom>
-          <a:noFill/>
-          <a:ln w="25400">
-            <a:solidFill>
-              <a:srgbClr val="059669"/>
-            </a:solidFill>
-            <a:prstDash val="solid"/>
-          </a:ln>
-        </p:spPr>
-      </p:sp>
-      <p:sp>
-        <p:nvSpPr>
-          <p:cNvPr id="27" name="Text 25"/>
-          <p:cNvSpPr/>
-          <p:nvPr/>
-        </p:nvSpPr>
-        <p:spPr>
-          <a:xfrm>
-            <a:off x="9272016" y="4434840"/>
-            <a:ext cx="2148840" cy="1280160"/>
-          </a:xfrm>
-          <a:prstGeom prst="rect">
-            <a:avLst/>
-          </a:prstGeom>
-          <a:noFill/>
-          <a:ln/>
-        </p:spPr>
-        <p:txBody>
-          <a:bodyPr wrap="square" lIns="0" tIns="0" rIns="0" bIns="0" rtlCol="0" anchor="ctr"/>
-          <a:lstStyle/>
-          <a:p>
-            <a:pPr indent="0" marL="0">
-              <a:buNone/>
-            </a:pPr>
-            <a:r>
-              <a:rPr lang="en-US" sz="1200" dirty="0">
-                <a:solidFill>
-                  <a:srgbClr val="6B5E62"/>
-                </a:solidFill>
-                <a:latin typeface="Calibri" pitchFamily="34" charset="0"/>
-                <a:ea typeface="Calibri" pitchFamily="34" charset="-122"/>
-                <a:cs typeface="Calibri" pitchFamily="34" charset="-120"/>
-              </a:rPr>
-              <a:t>A complete retirement experience supports premium advisory fees. You're delivering more — charge for it.</a:t>
-            </a:r>
-            <a:endParaRPr lang="en-US" sz="1200" dirty="0"/>
-          </a:p>
-        </p:txBody>
-      </p:sp>
-      <p:sp>
-        <p:nvSpPr>
-          <p:cNvPr id="28" name="Text 26"/>
-          <p:cNvSpPr/>
-          <p:nvPr/>
-        </p:nvSpPr>
-        <p:spPr>
-          <a:xfrm>
-            <a:off x="548640" y="6035040"/>
-            <a:ext cx="10972800" cy="274320"/>
-          </a:xfrm>
-          <a:prstGeom prst="rect">
-            <a:avLst/>
-          </a:prstGeom>
-          <a:noFill/>
-          <a:ln/>
-        </p:spPr>
-        <p:txBody>
-          <a:bodyPr wrap="square" lIns="0" tIns="0" rIns="0" bIns="0" rtlCol="0" anchor="ctr"/>
-          <a:lstStyle/>
-          <a:p>
-            <a:pPr algn="ctr" indent="0" marL="0">
-              <a:buNone/>
-            </a:pPr>
-            <a:r>
-              <a:rPr lang="en-US" sz="1400" i="1" dirty="0">
-                <a:solidFill>
-                  <a:srgbClr val="6B5E62"/>
-                </a:solidFill>
-                <a:latin typeface="Calibri" pitchFamily="34" charset="0"/>
-                <a:ea typeface="Calibri" pitchFamily="34" charset="-122"/>
-                <a:cs typeface="Calibri" pitchFamily="34" charset="-120"/>
-              </a:rPr>
-              <a:t>You're not adding a tool. You're adding a </a:t>
-            </a:r>
-            <a:pPr algn="ctr" indent="0" marL="0">
-              <a:buNone/>
-            </a:pPr>
-            <a:r>
-              <a:rPr lang="en-US" sz="1400" b="1" i="1" dirty="0">
-                <a:solidFill>
-                  <a:srgbClr val="2A354A"/>
-                </a:solidFill>
-                <a:latin typeface="Calibri" pitchFamily="34" charset="0"/>
-                <a:ea typeface="Calibri" pitchFamily="34" charset="-122"/>
-                <a:cs typeface="Calibri" pitchFamily="34" charset="-120"/>
-              </a:rPr>
-              <a:t>category of service</a:t>
-            </a:r>
-            <a:pPr algn="ctr" indent="0" marL="0">
-              <a:buNone/>
-            </a:pPr>
-            <a:r>
-              <a:rPr lang="en-US" sz="1400" i="1" dirty="0">
-                <a:solidFill>
-                  <a:srgbClr val="6B5E62"/>
-                </a:solidFill>
-                <a:latin typeface="Calibri" pitchFamily="34" charset="0"/>
-                <a:ea typeface="Calibri" pitchFamily="34" charset="-122"/>
-                <a:cs typeface="Calibri" pitchFamily="34" charset="-120"/>
-              </a:rPr>
-              <a:t> that nobody else in your zip code offers.</a:t>
-            </a:r>
-            <a:endParaRPr lang="en-US" sz="1400" dirty="0"/>
-          </a:p>
-        </p:txBody>
-      </p:sp>
-      <p:sp>
-        <p:nvSpPr>
-          <p:cNvPr id="29" name="Shape 27"/>
-          <p:cNvSpPr/>
-          <p:nvPr/>
-        </p:nvSpPr>
-        <p:spPr>
-          <a:xfrm>
-            <a:off x="548640" y="6446520"/>
-            <a:ext cx="11091672" cy="0"/>
-          </a:xfrm>
-          <a:prstGeom prst="line">
-            <a:avLst/>
-          </a:prstGeom>
-          <a:noFill/>
-          <a:ln w="9525">
-            <a:solidFill>
-              <a:srgbClr val="E5E7EB"/>
-            </a:solidFill>
-            <a:prstDash val="solid"/>
-          </a:ln>
-        </p:spPr>
-      </p:sp>
-      <p:sp>
-        <p:nvSpPr>
-          <p:cNvPr id="30" name="Text 28"/>
           <p:cNvSpPr/>
           <p:nvPr/>
         </p:nvSpPr>
@@ -4730,7 +4538,7 @@
       </p:sp>
       <p:sp>
         <p:nvSpPr>
-          <p:cNvPr id="31" name="Text 29"/>
+          <p:cNvPr id="25" name="Text 23"/>
           <p:cNvSpPr/>
           <p:nvPr/>
         </p:nvSpPr>
@@ -5194,8 +5002,8 @@
         </p:nvSpPr>
         <p:spPr>
           <a:xfrm>
-            <a:off x="914400" y="4160520"/>
-            <a:ext cx="2926080" cy="292608"/>
+            <a:off x="914400" y="4142232"/>
+            <a:ext cx="2926080" cy="256032"/>
           </a:xfrm>
           <a:prstGeom prst="rect">
             <a:avLst/>
@@ -5233,7 +5041,46 @@
         </p:nvSpPr>
         <p:spPr>
           <a:xfrm>
-            <a:off x="914400" y="4572000"/>
+            <a:off x="914400" y="4379976"/>
+            <a:ext cx="2926080" cy="219456"/>
+          </a:xfrm>
+          <a:prstGeom prst="rect">
+            <a:avLst/>
+          </a:prstGeom>
+          <a:noFill/>
+          <a:ln/>
+        </p:spPr>
+        <p:txBody>
+          <a:bodyPr wrap="square" lIns="0" tIns="0" rIns="0" bIns="0" rtlCol="0" anchor="ctr"/>
+          <a:lstStyle/>
+          <a:p>
+            <a:pPr indent="0" marL="0">
+              <a:buNone/>
+            </a:pPr>
+            <a:r>
+              <a:rPr lang="en-US" sz="1000" i="1" dirty="0">
+                <a:solidFill>
+                  <a:srgbClr val="9CA8C2"/>
+                </a:solidFill>
+                <a:latin typeface="Calibri" pitchFamily="34" charset="0"/>
+                <a:ea typeface="Calibri" pitchFamily="34" charset="-122"/>
+                <a:cs typeface="Calibri" pitchFamily="34" charset="-120"/>
+              </a:rPr>
+              <a:t>≈ $3.95 per client / mo</a:t>
+            </a:r>
+            <a:endParaRPr lang="en-US" sz="1000" dirty="0"/>
+          </a:p>
+        </p:txBody>
+      </p:sp>
+      <p:sp>
+        <p:nvSpPr>
+          <p:cNvPr id="15" name="Text 13"/>
+          <p:cNvSpPr/>
+          <p:nvPr/>
+        </p:nvSpPr>
+        <p:spPr>
+          <a:xfrm>
+            <a:off x="914400" y="4636008"/>
             <a:ext cx="182880" cy="228600"/>
           </a:xfrm>
           <a:prstGeom prst="rect">
@@ -5266,13 +5113,13 @@
       </p:sp>
       <p:sp>
         <p:nvSpPr>
-          <p:cNvPr id="15" name="Text 13"/>
-          <p:cNvSpPr/>
-          <p:nvPr/>
-        </p:nvSpPr>
-        <p:spPr>
-          <a:xfrm>
-            <a:off x="1143000" y="4572000"/>
+          <p:cNvPr id="16" name="Text 14"/>
+          <p:cNvSpPr/>
+          <p:nvPr/>
+        </p:nvSpPr>
+        <p:spPr>
+          <a:xfrm>
+            <a:off x="1143000" y="4636008"/>
             <a:ext cx="2788920" cy="228600"/>
           </a:xfrm>
           <a:prstGeom prst="rect">
@@ -5305,13 +5152,13 @@
       </p:sp>
       <p:sp>
         <p:nvSpPr>
-          <p:cNvPr id="16" name="Text 14"/>
-          <p:cNvSpPr/>
-          <p:nvPr/>
-        </p:nvSpPr>
-        <p:spPr>
-          <a:xfrm>
-            <a:off x="914400" y="4800600"/>
+          <p:cNvPr id="17" name="Text 15"/>
+          <p:cNvSpPr/>
+          <p:nvPr/>
+        </p:nvSpPr>
+        <p:spPr>
+          <a:xfrm>
+            <a:off x="914400" y="4864608"/>
             <a:ext cx="182880" cy="228600"/>
           </a:xfrm>
           <a:prstGeom prst="rect">
@@ -5344,13 +5191,13 @@
       </p:sp>
       <p:sp>
         <p:nvSpPr>
-          <p:cNvPr id="17" name="Text 15"/>
-          <p:cNvSpPr/>
-          <p:nvPr/>
-        </p:nvSpPr>
-        <p:spPr>
-          <a:xfrm>
-            <a:off x="1143000" y="4800600"/>
+          <p:cNvPr id="18" name="Text 16"/>
+          <p:cNvSpPr/>
+          <p:nvPr/>
+        </p:nvSpPr>
+        <p:spPr>
+          <a:xfrm>
+            <a:off x="1143000" y="4864608"/>
             <a:ext cx="2788920" cy="228600"/>
           </a:xfrm>
           <a:prstGeom prst="rect">
@@ -5383,13 +5230,13 @@
       </p:sp>
       <p:sp>
         <p:nvSpPr>
-          <p:cNvPr id="18" name="Text 16"/>
-          <p:cNvSpPr/>
-          <p:nvPr/>
-        </p:nvSpPr>
-        <p:spPr>
-          <a:xfrm>
-            <a:off x="914400" y="5029200"/>
+          <p:cNvPr id="19" name="Text 17"/>
+          <p:cNvSpPr/>
+          <p:nvPr/>
+        </p:nvSpPr>
+        <p:spPr>
+          <a:xfrm>
+            <a:off x="914400" y="5093208"/>
             <a:ext cx="182880" cy="228600"/>
           </a:xfrm>
           <a:prstGeom prst="rect">
@@ -5422,13 +5269,13 @@
       </p:sp>
       <p:sp>
         <p:nvSpPr>
-          <p:cNvPr id="19" name="Text 17"/>
-          <p:cNvSpPr/>
-          <p:nvPr/>
-        </p:nvSpPr>
-        <p:spPr>
-          <a:xfrm>
-            <a:off x="1143000" y="5029200"/>
+          <p:cNvPr id="20" name="Text 18"/>
+          <p:cNvSpPr/>
+          <p:nvPr/>
+        </p:nvSpPr>
+        <p:spPr>
+          <a:xfrm>
+            <a:off x="1143000" y="5093208"/>
             <a:ext cx="2788920" cy="228600"/>
           </a:xfrm>
           <a:prstGeom prst="rect">
@@ -5461,13 +5308,13 @@
       </p:sp>
       <p:sp>
         <p:nvSpPr>
-          <p:cNvPr id="20" name="Text 18"/>
-          <p:cNvSpPr/>
-          <p:nvPr/>
-        </p:nvSpPr>
-        <p:spPr>
-          <a:xfrm>
-            <a:off x="914400" y="5257800"/>
+          <p:cNvPr id="21" name="Text 19"/>
+          <p:cNvSpPr/>
+          <p:nvPr/>
+        </p:nvSpPr>
+        <p:spPr>
+          <a:xfrm>
+            <a:off x="914400" y="5321808"/>
             <a:ext cx="182880" cy="228600"/>
           </a:xfrm>
           <a:prstGeom prst="rect">
@@ -5500,13 +5347,13 @@
       </p:sp>
       <p:sp>
         <p:nvSpPr>
-          <p:cNvPr id="21" name="Text 19"/>
-          <p:cNvSpPr/>
-          <p:nvPr/>
-        </p:nvSpPr>
-        <p:spPr>
-          <a:xfrm>
-            <a:off x="1143000" y="5257800"/>
+          <p:cNvPr id="22" name="Text 20"/>
+          <p:cNvSpPr/>
+          <p:nvPr/>
+        </p:nvSpPr>
+        <p:spPr>
+          <a:xfrm>
+            <a:off x="1143000" y="5321808"/>
             <a:ext cx="2788920" cy="228600"/>
           </a:xfrm>
           <a:prstGeom prst="rect">
@@ -5539,13 +5386,13 @@
       </p:sp>
       <p:sp>
         <p:nvSpPr>
-          <p:cNvPr id="22" name="Text 20"/>
-          <p:cNvSpPr/>
-          <p:nvPr/>
-        </p:nvSpPr>
-        <p:spPr>
-          <a:xfrm>
-            <a:off x="914400" y="5486400"/>
+          <p:cNvPr id="23" name="Text 21"/>
+          <p:cNvSpPr/>
+          <p:nvPr/>
+        </p:nvSpPr>
+        <p:spPr>
+          <a:xfrm>
+            <a:off x="914400" y="5550408"/>
             <a:ext cx="182880" cy="228600"/>
           </a:xfrm>
           <a:prstGeom prst="rect">
@@ -5578,13 +5425,13 @@
       </p:sp>
       <p:sp>
         <p:nvSpPr>
-          <p:cNvPr id="23" name="Text 21"/>
-          <p:cNvSpPr/>
-          <p:nvPr/>
-        </p:nvSpPr>
-        <p:spPr>
-          <a:xfrm>
-            <a:off x="1143000" y="5486400"/>
+          <p:cNvPr id="24" name="Text 22"/>
+          <p:cNvSpPr/>
+          <p:nvPr/>
+        </p:nvSpPr>
+        <p:spPr>
+          <a:xfrm>
+            <a:off x="1143000" y="5550408"/>
             <a:ext cx="2788920" cy="228600"/>
           </a:xfrm>
           <a:prstGeom prst="rect">
@@ -5617,13 +5464,13 @@
       </p:sp>
       <p:sp>
         <p:nvSpPr>
-          <p:cNvPr id="24" name="Text 22"/>
-          <p:cNvSpPr/>
-          <p:nvPr/>
-        </p:nvSpPr>
-        <p:spPr>
-          <a:xfrm>
-            <a:off x="914400" y="5715000"/>
+          <p:cNvPr id="25" name="Text 23"/>
+          <p:cNvSpPr/>
+          <p:nvPr/>
+        </p:nvSpPr>
+        <p:spPr>
+          <a:xfrm>
+            <a:off x="914400" y="5779008"/>
             <a:ext cx="182880" cy="228600"/>
           </a:xfrm>
           <a:prstGeom prst="rect">
@@ -5656,13 +5503,13 @@
       </p:sp>
       <p:sp>
         <p:nvSpPr>
-          <p:cNvPr id="25" name="Text 23"/>
-          <p:cNvSpPr/>
-          <p:nvPr/>
-        </p:nvSpPr>
-        <p:spPr>
-          <a:xfrm>
-            <a:off x="1143000" y="5715000"/>
+          <p:cNvPr id="26" name="Text 24"/>
+          <p:cNvSpPr/>
+          <p:nvPr/>
+        </p:nvSpPr>
+        <p:spPr>
+          <a:xfrm>
+            <a:off x="1143000" y="5779008"/>
             <a:ext cx="2788920" cy="228600"/>
           </a:xfrm>
           <a:prstGeom prst="rect">
@@ -5695,13 +5542,13 @@
       </p:sp>
       <p:sp>
         <p:nvSpPr>
-          <p:cNvPr id="26" name="Text 24"/>
-          <p:cNvSpPr/>
-          <p:nvPr/>
-        </p:nvSpPr>
-        <p:spPr>
-          <a:xfrm>
-            <a:off x="914400" y="5943600"/>
+          <p:cNvPr id="27" name="Text 25"/>
+          <p:cNvSpPr/>
+          <p:nvPr/>
+        </p:nvSpPr>
+        <p:spPr>
+          <a:xfrm>
+            <a:off x="914400" y="6007608"/>
             <a:ext cx="182880" cy="228600"/>
           </a:xfrm>
           <a:prstGeom prst="rect">
@@ -5734,13 +5581,13 @@
       </p:sp>
       <p:sp>
         <p:nvSpPr>
-          <p:cNvPr id="27" name="Text 25"/>
-          <p:cNvSpPr/>
-          <p:nvPr/>
-        </p:nvSpPr>
-        <p:spPr>
-          <a:xfrm>
-            <a:off x="1143000" y="5943600"/>
+          <p:cNvPr id="28" name="Text 26"/>
+          <p:cNvSpPr/>
+          <p:nvPr/>
+        </p:nvSpPr>
+        <p:spPr>
+          <a:xfrm>
+            <a:off x="1143000" y="6007608"/>
             <a:ext cx="2788920" cy="228600"/>
           </a:xfrm>
           <a:prstGeom prst="rect">
@@ -5773,13 +5620,13 @@
       </p:sp>
       <p:sp>
         <p:nvSpPr>
-          <p:cNvPr id="28" name="Text 26"/>
-          <p:cNvSpPr/>
-          <p:nvPr/>
-        </p:nvSpPr>
-        <p:spPr>
-          <a:xfrm>
-            <a:off x="914400" y="6172200"/>
+          <p:cNvPr id="29" name="Text 27"/>
+          <p:cNvSpPr/>
+          <p:nvPr/>
+        </p:nvSpPr>
+        <p:spPr>
+          <a:xfrm>
+            <a:off x="914400" y="6236208"/>
             <a:ext cx="182880" cy="228600"/>
           </a:xfrm>
           <a:prstGeom prst="rect">
@@ -5812,13 +5659,13 @@
       </p:sp>
       <p:sp>
         <p:nvSpPr>
-          <p:cNvPr id="29" name="Text 27"/>
-          <p:cNvSpPr/>
-          <p:nvPr/>
-        </p:nvSpPr>
-        <p:spPr>
-          <a:xfrm>
-            <a:off x="1143000" y="6172200"/>
+          <p:cNvPr id="30" name="Text 28"/>
+          <p:cNvSpPr/>
+          <p:nvPr/>
+        </p:nvSpPr>
+        <p:spPr>
+          <a:xfrm>
+            <a:off x="1143000" y="6236208"/>
             <a:ext cx="2788920" cy="228600"/>
           </a:xfrm>
           <a:prstGeom prst="rect">
@@ -5851,7 +5698,7 @@
       </p:sp>
       <p:sp>
         <p:nvSpPr>
-          <p:cNvPr id="30" name="Shape 28"/>
+          <p:cNvPr id="31" name="Shape 29"/>
           <p:cNvSpPr/>
           <p:nvPr/>
         </p:nvSpPr>
@@ -5883,7 +5730,7 @@
       </p:sp>
       <p:sp>
         <p:nvSpPr>
-          <p:cNvPr id="31" name="Shape 29"/>
+          <p:cNvPr id="32" name="Shape 30"/>
           <p:cNvSpPr/>
           <p:nvPr/>
         </p:nvSpPr>
@@ -5905,7 +5752,7 @@
       </p:sp>
       <p:sp>
         <p:nvSpPr>
-          <p:cNvPr id="32" name="Text 30"/>
+          <p:cNvPr id="33" name="Text 31"/>
           <p:cNvSpPr/>
           <p:nvPr/>
         </p:nvSpPr>
@@ -5944,7 +5791,7 @@
       </p:sp>
       <p:sp>
         <p:nvSpPr>
-          <p:cNvPr id="33" name="Text 31"/>
+          <p:cNvPr id="34" name="Text 32"/>
           <p:cNvSpPr/>
           <p:nvPr/>
         </p:nvSpPr>
@@ -5983,7 +5830,7 @@
       </p:sp>
       <p:sp>
         <p:nvSpPr>
-          <p:cNvPr id="34" name="Text 32"/>
+          <p:cNvPr id="35" name="Text 33"/>
           <p:cNvSpPr/>
           <p:nvPr/>
         </p:nvSpPr>
@@ -6022,7 +5869,7 @@
       </p:sp>
       <p:sp>
         <p:nvSpPr>
-          <p:cNvPr id="35" name="Text 33"/>
+          <p:cNvPr id="36" name="Text 34"/>
           <p:cNvSpPr/>
           <p:nvPr/>
         </p:nvSpPr>
@@ -6061,7 +5908,7 @@
       </p:sp>
       <p:sp>
         <p:nvSpPr>
-          <p:cNvPr id="36" name="Text 34"/>
+          <p:cNvPr id="37" name="Text 35"/>
           <p:cNvSpPr/>
           <p:nvPr/>
         </p:nvSpPr>
@@ -6100,7 +5947,7 @@
       </p:sp>
       <p:sp>
         <p:nvSpPr>
-          <p:cNvPr id="37" name="Text 35"/>
+          <p:cNvPr id="38" name="Text 36"/>
           <p:cNvSpPr/>
           <p:nvPr/>
         </p:nvSpPr>
@@ -6139,7 +5986,7 @@
       </p:sp>
       <p:sp>
         <p:nvSpPr>
-          <p:cNvPr id="38" name="Shape 36"/>
+          <p:cNvPr id="39" name="Shape 37"/>
           <p:cNvSpPr/>
           <p:nvPr/>
         </p:nvSpPr>
@@ -6162,14 +6009,14 @@
       </p:sp>
       <p:sp>
         <p:nvSpPr>
-          <p:cNvPr id="39" name="Text 37"/>
-          <p:cNvSpPr/>
-          <p:nvPr/>
-        </p:nvSpPr>
-        <p:spPr>
-          <a:xfrm>
-            <a:off x="4709160" y="4160520"/>
-            <a:ext cx="2926080" cy="292608"/>
+          <p:cNvPr id="40" name="Text 38"/>
+          <p:cNvSpPr/>
+          <p:nvPr/>
+        </p:nvSpPr>
+        <p:spPr>
+          <a:xfrm>
+            <a:off x="4709160" y="4142232"/>
+            <a:ext cx="2926080" cy="256032"/>
           </a:xfrm>
           <a:prstGeom prst="rect">
             <a:avLst/>
@@ -6201,13 +6048,52 @@
       </p:sp>
       <p:sp>
         <p:nvSpPr>
-          <p:cNvPr id="40" name="Text 38"/>
-          <p:cNvSpPr/>
-          <p:nvPr/>
-        </p:nvSpPr>
-        <p:spPr>
-          <a:xfrm>
-            <a:off x="4709160" y="4572000"/>
+          <p:cNvPr id="41" name="Text 39"/>
+          <p:cNvSpPr/>
+          <p:nvPr/>
+        </p:nvSpPr>
+        <p:spPr>
+          <a:xfrm>
+            <a:off x="4709160" y="4379976"/>
+            <a:ext cx="2926080" cy="219456"/>
+          </a:xfrm>
+          <a:prstGeom prst="rect">
+            <a:avLst/>
+          </a:prstGeom>
+          <a:noFill/>
+          <a:ln/>
+        </p:spPr>
+        <p:txBody>
+          <a:bodyPr wrap="square" lIns="0" tIns="0" rIns="0" bIns="0" rtlCol="0" anchor="ctr"/>
+          <a:lstStyle/>
+          <a:p>
+            <a:pPr indent="0" marL="0">
+              <a:buNone/>
+            </a:pPr>
+            <a:r>
+              <a:rPr lang="en-US" sz="1000" i="1" dirty="0">
+                <a:solidFill>
+                  <a:srgbClr val="9CA8C2"/>
+                </a:solidFill>
+                <a:latin typeface="Calibri" pitchFamily="34" charset="0"/>
+                <a:ea typeface="Calibri" pitchFamily="34" charset="-122"/>
+                <a:cs typeface="Calibri" pitchFamily="34" charset="-120"/>
+              </a:rPr>
+              <a:t>≈ $3.53 per client / mo</a:t>
+            </a:r>
+            <a:endParaRPr lang="en-US" sz="1000" dirty="0"/>
+          </a:p>
+        </p:txBody>
+      </p:sp>
+      <p:sp>
+        <p:nvSpPr>
+          <p:cNvPr id="42" name="Text 40"/>
+          <p:cNvSpPr/>
+          <p:nvPr/>
+        </p:nvSpPr>
+        <p:spPr>
+          <a:xfrm>
+            <a:off x="4709160" y="4636008"/>
             <a:ext cx="182880" cy="228600"/>
           </a:xfrm>
           <a:prstGeom prst="rect">
@@ -6240,13 +6126,13 @@
       </p:sp>
       <p:sp>
         <p:nvSpPr>
-          <p:cNvPr id="41" name="Text 39"/>
-          <p:cNvSpPr/>
-          <p:nvPr/>
-        </p:nvSpPr>
-        <p:spPr>
-          <a:xfrm>
-            <a:off x="4937760" y="4572000"/>
+          <p:cNvPr id="43" name="Text 41"/>
+          <p:cNvSpPr/>
+          <p:nvPr/>
+        </p:nvSpPr>
+        <p:spPr>
+          <a:xfrm>
+            <a:off x="4937760" y="4636008"/>
             <a:ext cx="2788920" cy="228600"/>
           </a:xfrm>
           <a:prstGeom prst="rect">
@@ -6279,13 +6165,13 @@
       </p:sp>
       <p:sp>
         <p:nvSpPr>
-          <p:cNvPr id="42" name="Text 40"/>
-          <p:cNvSpPr/>
-          <p:nvPr/>
-        </p:nvSpPr>
-        <p:spPr>
-          <a:xfrm>
-            <a:off x="4709160" y="4800600"/>
+          <p:cNvPr id="44" name="Text 42"/>
+          <p:cNvSpPr/>
+          <p:nvPr/>
+        </p:nvSpPr>
+        <p:spPr>
+          <a:xfrm>
+            <a:off x="4709160" y="4864608"/>
             <a:ext cx="182880" cy="228600"/>
           </a:xfrm>
           <a:prstGeom prst="rect">
@@ -6318,13 +6204,13 @@
       </p:sp>
       <p:sp>
         <p:nvSpPr>
-          <p:cNvPr id="43" name="Text 41"/>
-          <p:cNvSpPr/>
-          <p:nvPr/>
-        </p:nvSpPr>
-        <p:spPr>
-          <a:xfrm>
-            <a:off x="4937760" y="4800600"/>
+          <p:cNvPr id="45" name="Text 43"/>
+          <p:cNvSpPr/>
+          <p:nvPr/>
+        </p:nvSpPr>
+        <p:spPr>
+          <a:xfrm>
+            <a:off x="4937760" y="4864608"/>
             <a:ext cx="2788920" cy="228600"/>
           </a:xfrm>
           <a:prstGeom prst="rect">
@@ -6357,13 +6243,13 @@
       </p:sp>
       <p:sp>
         <p:nvSpPr>
-          <p:cNvPr id="44" name="Text 42"/>
-          <p:cNvSpPr/>
-          <p:nvPr/>
-        </p:nvSpPr>
-        <p:spPr>
-          <a:xfrm>
-            <a:off x="4709160" y="5029200"/>
+          <p:cNvPr id="46" name="Text 44"/>
+          <p:cNvSpPr/>
+          <p:nvPr/>
+        </p:nvSpPr>
+        <p:spPr>
+          <a:xfrm>
+            <a:off x="4709160" y="5093208"/>
             <a:ext cx="182880" cy="228600"/>
           </a:xfrm>
           <a:prstGeom prst="rect">
@@ -6396,13 +6282,13 @@
       </p:sp>
       <p:sp>
         <p:nvSpPr>
-          <p:cNvPr id="45" name="Text 43"/>
-          <p:cNvSpPr/>
-          <p:nvPr/>
-        </p:nvSpPr>
-        <p:spPr>
-          <a:xfrm>
-            <a:off x="4937760" y="5029200"/>
+          <p:cNvPr id="47" name="Text 45"/>
+          <p:cNvSpPr/>
+          <p:nvPr/>
+        </p:nvSpPr>
+        <p:spPr>
+          <a:xfrm>
+            <a:off x="4937760" y="5093208"/>
             <a:ext cx="2788920" cy="228600"/>
           </a:xfrm>
           <a:prstGeom prst="rect">
@@ -6435,13 +6321,13 @@
       </p:sp>
       <p:sp>
         <p:nvSpPr>
-          <p:cNvPr id="46" name="Text 44"/>
-          <p:cNvSpPr/>
-          <p:nvPr/>
-        </p:nvSpPr>
-        <p:spPr>
-          <a:xfrm>
-            <a:off x="4709160" y="5257800"/>
+          <p:cNvPr id="48" name="Text 46"/>
+          <p:cNvSpPr/>
+          <p:nvPr/>
+        </p:nvSpPr>
+        <p:spPr>
+          <a:xfrm>
+            <a:off x="4709160" y="5321808"/>
             <a:ext cx="182880" cy="228600"/>
           </a:xfrm>
           <a:prstGeom prst="rect">
@@ -6474,13 +6360,13 @@
       </p:sp>
       <p:sp>
         <p:nvSpPr>
-          <p:cNvPr id="47" name="Text 45"/>
-          <p:cNvSpPr/>
-          <p:nvPr/>
-        </p:nvSpPr>
-        <p:spPr>
-          <a:xfrm>
-            <a:off x="4937760" y="5257800"/>
+          <p:cNvPr id="49" name="Text 47"/>
+          <p:cNvSpPr/>
+          <p:nvPr/>
+        </p:nvSpPr>
+        <p:spPr>
+          <a:xfrm>
+            <a:off x="4937760" y="5321808"/>
             <a:ext cx="2788920" cy="228600"/>
           </a:xfrm>
           <a:prstGeom prst="rect">
@@ -6513,13 +6399,13 @@
       </p:sp>
       <p:sp>
         <p:nvSpPr>
-          <p:cNvPr id="48" name="Text 46"/>
-          <p:cNvSpPr/>
-          <p:nvPr/>
-        </p:nvSpPr>
-        <p:spPr>
-          <a:xfrm>
-            <a:off x="4709160" y="5486400"/>
+          <p:cNvPr id="50" name="Text 48"/>
+          <p:cNvSpPr/>
+          <p:nvPr/>
+        </p:nvSpPr>
+        <p:spPr>
+          <a:xfrm>
+            <a:off x="4709160" y="5550408"/>
             <a:ext cx="182880" cy="228600"/>
           </a:xfrm>
           <a:prstGeom prst="rect">
@@ -6552,13 +6438,13 @@
       </p:sp>
       <p:sp>
         <p:nvSpPr>
-          <p:cNvPr id="49" name="Text 47"/>
-          <p:cNvSpPr/>
-          <p:nvPr/>
-        </p:nvSpPr>
-        <p:spPr>
-          <a:xfrm>
-            <a:off x="4937760" y="5486400"/>
+          <p:cNvPr id="51" name="Text 49"/>
+          <p:cNvSpPr/>
+          <p:nvPr/>
+        </p:nvSpPr>
+        <p:spPr>
+          <a:xfrm>
+            <a:off x="4937760" y="5550408"/>
             <a:ext cx="2788920" cy="228600"/>
           </a:xfrm>
           <a:prstGeom prst="rect">
@@ -6591,13 +6477,13 @@
       </p:sp>
       <p:sp>
         <p:nvSpPr>
-          <p:cNvPr id="50" name="Text 48"/>
-          <p:cNvSpPr/>
-          <p:nvPr/>
-        </p:nvSpPr>
-        <p:spPr>
-          <a:xfrm>
-            <a:off x="4709160" y="5715000"/>
+          <p:cNvPr id="52" name="Text 50"/>
+          <p:cNvSpPr/>
+          <p:nvPr/>
+        </p:nvSpPr>
+        <p:spPr>
+          <a:xfrm>
+            <a:off x="4709160" y="5779008"/>
             <a:ext cx="182880" cy="228600"/>
           </a:xfrm>
           <a:prstGeom prst="rect">
@@ -6630,13 +6516,13 @@
       </p:sp>
       <p:sp>
         <p:nvSpPr>
-          <p:cNvPr id="51" name="Text 49"/>
-          <p:cNvSpPr/>
-          <p:nvPr/>
-        </p:nvSpPr>
-        <p:spPr>
-          <a:xfrm>
-            <a:off x="4937760" y="5715000"/>
+          <p:cNvPr id="53" name="Text 51"/>
+          <p:cNvSpPr/>
+          <p:nvPr/>
+        </p:nvSpPr>
+        <p:spPr>
+          <a:xfrm>
+            <a:off x="4937760" y="5779008"/>
             <a:ext cx="2788920" cy="228600"/>
           </a:xfrm>
           <a:prstGeom prst="rect">
@@ -6669,13 +6555,13 @@
       </p:sp>
       <p:sp>
         <p:nvSpPr>
-          <p:cNvPr id="52" name="Text 50"/>
-          <p:cNvSpPr/>
-          <p:nvPr/>
-        </p:nvSpPr>
-        <p:spPr>
-          <a:xfrm>
-            <a:off x="4709160" y="5943600"/>
+          <p:cNvPr id="54" name="Text 52"/>
+          <p:cNvSpPr/>
+          <p:nvPr/>
+        </p:nvSpPr>
+        <p:spPr>
+          <a:xfrm>
+            <a:off x="4709160" y="6007608"/>
             <a:ext cx="182880" cy="228600"/>
           </a:xfrm>
           <a:prstGeom prst="rect">
@@ -6708,13 +6594,13 @@
       </p:sp>
       <p:sp>
         <p:nvSpPr>
-          <p:cNvPr id="53" name="Text 51"/>
-          <p:cNvSpPr/>
-          <p:nvPr/>
-        </p:nvSpPr>
-        <p:spPr>
-          <a:xfrm>
-            <a:off x="4937760" y="5943600"/>
+          <p:cNvPr id="55" name="Text 53"/>
+          <p:cNvSpPr/>
+          <p:nvPr/>
+        </p:nvSpPr>
+        <p:spPr>
+          <a:xfrm>
+            <a:off x="4937760" y="6007608"/>
             <a:ext cx="2788920" cy="228600"/>
           </a:xfrm>
           <a:prstGeom prst="rect">
@@ -6747,13 +6633,13 @@
       </p:sp>
       <p:sp>
         <p:nvSpPr>
-          <p:cNvPr id="54" name="Text 52"/>
-          <p:cNvSpPr/>
-          <p:nvPr/>
-        </p:nvSpPr>
-        <p:spPr>
-          <a:xfrm>
-            <a:off x="4709160" y="6172200"/>
+          <p:cNvPr id="56" name="Text 54"/>
+          <p:cNvSpPr/>
+          <p:nvPr/>
+        </p:nvSpPr>
+        <p:spPr>
+          <a:xfrm>
+            <a:off x="4709160" y="6236208"/>
             <a:ext cx="182880" cy="228600"/>
           </a:xfrm>
           <a:prstGeom prst="rect">
@@ -6786,13 +6672,13 @@
       </p:sp>
       <p:sp>
         <p:nvSpPr>
-          <p:cNvPr id="55" name="Text 53"/>
-          <p:cNvSpPr/>
-          <p:nvPr/>
-        </p:nvSpPr>
-        <p:spPr>
-          <a:xfrm>
-            <a:off x="4937760" y="6172200"/>
+          <p:cNvPr id="57" name="Text 55"/>
+          <p:cNvSpPr/>
+          <p:nvPr/>
+        </p:nvSpPr>
+        <p:spPr>
+          <a:xfrm>
+            <a:off x="4937760" y="6236208"/>
             <a:ext cx="2788920" cy="228600"/>
           </a:xfrm>
           <a:prstGeom prst="rect">
@@ -6825,7 +6711,7 @@
       </p:sp>
       <p:sp>
         <p:nvSpPr>
-          <p:cNvPr id="56" name="Shape 54"/>
+          <p:cNvPr id="58" name="Shape 56"/>
           <p:cNvSpPr/>
           <p:nvPr/>
         </p:nvSpPr>
@@ -6857,7 +6743,7 @@
       </p:sp>
       <p:sp>
         <p:nvSpPr>
-          <p:cNvPr id="57" name="Text 55"/>
+          <p:cNvPr id="59" name="Text 57"/>
           <p:cNvSpPr/>
           <p:nvPr/>
         </p:nvSpPr>
@@ -6896,7 +6782,7 @@
       </p:sp>
       <p:sp>
         <p:nvSpPr>
-          <p:cNvPr id="58" name="Text 56"/>
+          <p:cNvPr id="60" name="Text 58"/>
           <p:cNvSpPr/>
           <p:nvPr/>
         </p:nvSpPr>
@@ -6935,7 +6821,7 @@
       </p:sp>
       <p:sp>
         <p:nvSpPr>
-          <p:cNvPr id="59" name="Text 57"/>
+          <p:cNvPr id="61" name="Text 59"/>
           <p:cNvSpPr/>
           <p:nvPr/>
         </p:nvSpPr>
@@ -6974,7 +6860,7 @@
       </p:sp>
       <p:sp>
         <p:nvSpPr>
-          <p:cNvPr id="60" name="Text 58"/>
+          <p:cNvPr id="62" name="Text 60"/>
           <p:cNvSpPr/>
           <p:nvPr/>
         </p:nvSpPr>
@@ -7013,7 +6899,7 @@
       </p:sp>
       <p:sp>
         <p:nvSpPr>
-          <p:cNvPr id="61" name="Text 59"/>
+          <p:cNvPr id="63" name="Text 61"/>
           <p:cNvSpPr/>
           <p:nvPr/>
         </p:nvSpPr>
@@ -7052,7 +6938,7 @@
       </p:sp>
       <p:sp>
         <p:nvSpPr>
-          <p:cNvPr id="62" name="Shape 60"/>
+          <p:cNvPr id="64" name="Shape 62"/>
           <p:cNvSpPr/>
           <p:nvPr/>
         </p:nvSpPr>
@@ -7075,14 +6961,14 @@
       </p:sp>
       <p:sp>
         <p:nvSpPr>
-          <p:cNvPr id="63" name="Text 61"/>
-          <p:cNvSpPr/>
-          <p:nvPr/>
-        </p:nvSpPr>
-        <p:spPr>
-          <a:xfrm>
-            <a:off x="8503920" y="4160520"/>
-            <a:ext cx="2926080" cy="292608"/>
+          <p:cNvPr id="65" name="Text 63"/>
+          <p:cNvSpPr/>
+          <p:nvPr/>
+        </p:nvSpPr>
+        <p:spPr>
+          <a:xfrm>
+            <a:off x="8503920" y="4142232"/>
+            <a:ext cx="2926080" cy="256032"/>
           </a:xfrm>
           <a:prstGeom prst="rect">
             <a:avLst/>
@@ -7114,13 +7000,52 @@
       </p:sp>
       <p:sp>
         <p:nvSpPr>
-          <p:cNvPr id="64" name="Text 62"/>
-          <p:cNvSpPr/>
-          <p:nvPr/>
-        </p:nvSpPr>
-        <p:spPr>
-          <a:xfrm>
-            <a:off x="8503920" y="4572000"/>
+          <p:cNvPr id="66" name="Text 64"/>
+          <p:cNvSpPr/>
+          <p:nvPr/>
+        </p:nvSpPr>
+        <p:spPr>
+          <a:xfrm>
+            <a:off x="8503920" y="4379976"/>
+            <a:ext cx="2926080" cy="219456"/>
+          </a:xfrm>
+          <a:prstGeom prst="rect">
+            <a:avLst/>
+          </a:prstGeom>
+          <a:noFill/>
+          <a:ln/>
+        </p:spPr>
+        <p:txBody>
+          <a:bodyPr wrap="square" lIns="0" tIns="0" rIns="0" bIns="0" rtlCol="0" anchor="ctr"/>
+          <a:lstStyle/>
+          <a:p>
+            <a:pPr indent="0" marL="0">
+              <a:buNone/>
+            </a:pPr>
+            <a:r>
+              <a:rPr lang="en-US" sz="1000" i="1" dirty="0">
+                <a:solidFill>
+                  <a:srgbClr val="9CA8C2"/>
+                </a:solidFill>
+                <a:latin typeface="Calibri" pitchFamily="34" charset="0"/>
+                <a:ea typeface="Calibri" pitchFamily="34" charset="-122"/>
+                <a:cs typeface="Calibri" pitchFamily="34" charset="-120"/>
+              </a:rPr>
+              <a:t>≈ $3.99 / client at 100 — and falling</a:t>
+            </a:r>
+            <a:endParaRPr lang="en-US" sz="1000" dirty="0"/>
+          </a:p>
+        </p:txBody>
+      </p:sp>
+      <p:sp>
+        <p:nvSpPr>
+          <p:cNvPr id="67" name="Text 65"/>
+          <p:cNvSpPr/>
+          <p:nvPr/>
+        </p:nvSpPr>
+        <p:spPr>
+          <a:xfrm>
+            <a:off x="8503920" y="4636008"/>
             <a:ext cx="182880" cy="228600"/>
           </a:xfrm>
           <a:prstGeom prst="rect">
@@ -7153,13 +7078,13 @@
       </p:sp>
       <p:sp>
         <p:nvSpPr>
-          <p:cNvPr id="65" name="Text 63"/>
-          <p:cNvSpPr/>
-          <p:nvPr/>
-        </p:nvSpPr>
-        <p:spPr>
-          <a:xfrm>
-            <a:off x="8732520" y="4572000"/>
+          <p:cNvPr id="68" name="Text 66"/>
+          <p:cNvSpPr/>
+          <p:nvPr/>
+        </p:nvSpPr>
+        <p:spPr>
+          <a:xfrm>
+            <a:off x="8732520" y="4636008"/>
             <a:ext cx="2788920" cy="228600"/>
           </a:xfrm>
           <a:prstGeom prst="rect">
@@ -7192,13 +7117,13 @@
       </p:sp>
       <p:sp>
         <p:nvSpPr>
-          <p:cNvPr id="66" name="Text 64"/>
-          <p:cNvSpPr/>
-          <p:nvPr/>
-        </p:nvSpPr>
-        <p:spPr>
-          <a:xfrm>
-            <a:off x="8503920" y="4800600"/>
+          <p:cNvPr id="69" name="Text 67"/>
+          <p:cNvSpPr/>
+          <p:nvPr/>
+        </p:nvSpPr>
+        <p:spPr>
+          <a:xfrm>
+            <a:off x="8503920" y="4864608"/>
             <a:ext cx="182880" cy="228600"/>
           </a:xfrm>
           <a:prstGeom prst="rect">
@@ -7231,13 +7156,13 @@
       </p:sp>
       <p:sp>
         <p:nvSpPr>
-          <p:cNvPr id="67" name="Text 65"/>
-          <p:cNvSpPr/>
-          <p:nvPr/>
-        </p:nvSpPr>
-        <p:spPr>
-          <a:xfrm>
-            <a:off x="8732520" y="4800600"/>
+          <p:cNvPr id="70" name="Text 68"/>
+          <p:cNvSpPr/>
+          <p:nvPr/>
+        </p:nvSpPr>
+        <p:spPr>
+          <a:xfrm>
+            <a:off x="8732520" y="4864608"/>
             <a:ext cx="2788920" cy="228600"/>
           </a:xfrm>
           <a:prstGeom prst="rect">
@@ -7270,13 +7195,13 @@
       </p:sp>
       <p:sp>
         <p:nvSpPr>
-          <p:cNvPr id="68" name="Text 66"/>
-          <p:cNvSpPr/>
-          <p:nvPr/>
-        </p:nvSpPr>
-        <p:spPr>
-          <a:xfrm>
-            <a:off x="8503920" y="5029200"/>
+          <p:cNvPr id="71" name="Text 69"/>
+          <p:cNvSpPr/>
+          <p:nvPr/>
+        </p:nvSpPr>
+        <p:spPr>
+          <a:xfrm>
+            <a:off x="8503920" y="5093208"/>
             <a:ext cx="182880" cy="228600"/>
           </a:xfrm>
           <a:prstGeom prst="rect">
@@ -7309,13 +7234,13 @@
       </p:sp>
       <p:sp>
         <p:nvSpPr>
-          <p:cNvPr id="69" name="Text 67"/>
-          <p:cNvSpPr/>
-          <p:nvPr/>
-        </p:nvSpPr>
-        <p:spPr>
-          <a:xfrm>
-            <a:off x="8732520" y="5029200"/>
+          <p:cNvPr id="72" name="Text 70"/>
+          <p:cNvSpPr/>
+          <p:nvPr/>
+        </p:nvSpPr>
+        <p:spPr>
+          <a:xfrm>
+            <a:off x="8732520" y="5093208"/>
             <a:ext cx="2788920" cy="228600"/>
           </a:xfrm>
           <a:prstGeom prst="rect">
@@ -7348,13 +7273,13 @@
       </p:sp>
       <p:sp>
         <p:nvSpPr>
-          <p:cNvPr id="70" name="Text 68"/>
-          <p:cNvSpPr/>
-          <p:nvPr/>
-        </p:nvSpPr>
-        <p:spPr>
-          <a:xfrm>
-            <a:off x="8503920" y="5257800"/>
+          <p:cNvPr id="73" name="Text 71"/>
+          <p:cNvSpPr/>
+          <p:nvPr/>
+        </p:nvSpPr>
+        <p:spPr>
+          <a:xfrm>
+            <a:off x="8503920" y="5321808"/>
             <a:ext cx="182880" cy="228600"/>
           </a:xfrm>
           <a:prstGeom prst="rect">
@@ -7387,13 +7312,13 @@
       </p:sp>
       <p:sp>
         <p:nvSpPr>
-          <p:cNvPr id="71" name="Text 69"/>
-          <p:cNvSpPr/>
-          <p:nvPr/>
-        </p:nvSpPr>
-        <p:spPr>
-          <a:xfrm>
-            <a:off x="8732520" y="5257800"/>
+          <p:cNvPr id="74" name="Text 72"/>
+          <p:cNvSpPr/>
+          <p:nvPr/>
+        </p:nvSpPr>
+        <p:spPr>
+          <a:xfrm>
+            <a:off x="8732520" y="5321808"/>
             <a:ext cx="2788920" cy="228600"/>
           </a:xfrm>
           <a:prstGeom prst="rect">
@@ -7426,13 +7351,13 @@
       </p:sp>
       <p:sp>
         <p:nvSpPr>
-          <p:cNvPr id="72" name="Text 70"/>
-          <p:cNvSpPr/>
-          <p:nvPr/>
-        </p:nvSpPr>
-        <p:spPr>
-          <a:xfrm>
-            <a:off x="8503920" y="5486400"/>
+          <p:cNvPr id="75" name="Text 73"/>
+          <p:cNvSpPr/>
+          <p:nvPr/>
+        </p:nvSpPr>
+        <p:spPr>
+          <a:xfrm>
+            <a:off x="8503920" y="5550408"/>
             <a:ext cx="182880" cy="228600"/>
           </a:xfrm>
           <a:prstGeom prst="rect">
@@ -7465,13 +7390,13 @@
       </p:sp>
       <p:sp>
         <p:nvSpPr>
-          <p:cNvPr id="73" name="Text 71"/>
-          <p:cNvSpPr/>
-          <p:nvPr/>
-        </p:nvSpPr>
-        <p:spPr>
-          <a:xfrm>
-            <a:off x="8732520" y="5486400"/>
+          <p:cNvPr id="76" name="Text 74"/>
+          <p:cNvSpPr/>
+          <p:nvPr/>
+        </p:nvSpPr>
+        <p:spPr>
+          <a:xfrm>
+            <a:off x="8732520" y="5550408"/>
             <a:ext cx="2788920" cy="228600"/>
           </a:xfrm>
           <a:prstGeom prst="rect">
@@ -7504,13 +7429,13 @@
       </p:sp>
       <p:sp>
         <p:nvSpPr>
-          <p:cNvPr id="74" name="Text 72"/>
-          <p:cNvSpPr/>
-          <p:nvPr/>
-        </p:nvSpPr>
-        <p:spPr>
-          <a:xfrm>
-            <a:off x="8503920" y="5715000"/>
+          <p:cNvPr id="77" name="Text 75"/>
+          <p:cNvSpPr/>
+          <p:nvPr/>
+        </p:nvSpPr>
+        <p:spPr>
+          <a:xfrm>
+            <a:off x="8503920" y="5779008"/>
             <a:ext cx="182880" cy="228600"/>
           </a:xfrm>
           <a:prstGeom prst="rect">
@@ -7543,13 +7468,13 @@
       </p:sp>
       <p:sp>
         <p:nvSpPr>
-          <p:cNvPr id="75" name="Text 73"/>
-          <p:cNvSpPr/>
-          <p:nvPr/>
-        </p:nvSpPr>
-        <p:spPr>
-          <a:xfrm>
-            <a:off x="8732520" y="5715000"/>
+          <p:cNvPr id="78" name="Text 76"/>
+          <p:cNvSpPr/>
+          <p:nvPr/>
+        </p:nvSpPr>
+        <p:spPr>
+          <a:xfrm>
+            <a:off x="8732520" y="5779008"/>
             <a:ext cx="2788920" cy="228600"/>
           </a:xfrm>
           <a:prstGeom prst="rect">
@@ -7582,13 +7507,13 @@
       </p:sp>
       <p:sp>
         <p:nvSpPr>
-          <p:cNvPr id="76" name="Text 74"/>
-          <p:cNvSpPr/>
-          <p:nvPr/>
-        </p:nvSpPr>
-        <p:spPr>
-          <a:xfrm>
-            <a:off x="8503920" y="5943600"/>
+          <p:cNvPr id="79" name="Text 77"/>
+          <p:cNvSpPr/>
+          <p:nvPr/>
+        </p:nvSpPr>
+        <p:spPr>
+          <a:xfrm>
+            <a:off x="8503920" y="6007608"/>
             <a:ext cx="182880" cy="228600"/>
           </a:xfrm>
           <a:prstGeom prst="rect">
@@ -7621,13 +7546,13 @@
       </p:sp>
       <p:sp>
         <p:nvSpPr>
-          <p:cNvPr id="77" name="Text 75"/>
-          <p:cNvSpPr/>
-          <p:nvPr/>
-        </p:nvSpPr>
-        <p:spPr>
-          <a:xfrm>
-            <a:off x="8732520" y="5943600"/>
+          <p:cNvPr id="80" name="Text 78"/>
+          <p:cNvSpPr/>
+          <p:nvPr/>
+        </p:nvSpPr>
+        <p:spPr>
+          <a:xfrm>
+            <a:off x="8732520" y="6007608"/>
             <a:ext cx="2788920" cy="228600"/>
           </a:xfrm>
           <a:prstGeom prst="rect">
@@ -7660,13 +7585,13 @@
       </p:sp>
       <p:sp>
         <p:nvSpPr>
-          <p:cNvPr id="78" name="Text 76"/>
-          <p:cNvSpPr/>
-          <p:nvPr/>
-        </p:nvSpPr>
-        <p:spPr>
-          <a:xfrm>
-            <a:off x="8503920" y="6172200"/>
+          <p:cNvPr id="81" name="Text 79"/>
+          <p:cNvSpPr/>
+          <p:nvPr/>
+        </p:nvSpPr>
+        <p:spPr>
+          <a:xfrm>
+            <a:off x="8503920" y="6236208"/>
             <a:ext cx="182880" cy="228600"/>
           </a:xfrm>
           <a:prstGeom prst="rect">
@@ -7699,13 +7624,13 @@
       </p:sp>
       <p:sp>
         <p:nvSpPr>
-          <p:cNvPr id="79" name="Text 77"/>
-          <p:cNvSpPr/>
-          <p:nvPr/>
-        </p:nvSpPr>
-        <p:spPr>
-          <a:xfrm>
-            <a:off x="8732520" y="6172200"/>
+          <p:cNvPr id="82" name="Text 80"/>
+          <p:cNvSpPr/>
+          <p:nvPr/>
+        </p:nvSpPr>
+        <p:spPr>
+          <a:xfrm>
+            <a:off x="8732520" y="6236208"/>
             <a:ext cx="2788920" cy="228600"/>
           </a:xfrm>
           <a:prstGeom prst="rect">
@@ -7738,7 +7663,7 @@
       </p:sp>
       <p:sp>
         <p:nvSpPr>
-          <p:cNvPr id="80" name="Text 78"/>
+          <p:cNvPr id="83" name="Text 81"/>
           <p:cNvSpPr/>
           <p:nvPr/>
         </p:nvSpPr>
@@ -7777,7 +7702,7 @@
       </p:sp>
       <p:sp>
         <p:nvSpPr>
-          <p:cNvPr id="81" name="Shape 79"/>
+          <p:cNvPr id="84" name="Shape 82"/>
           <p:cNvSpPr/>
           <p:nvPr/>
         </p:nvSpPr>
@@ -7800,7 +7725,7 @@
       </p:sp>
       <p:sp>
         <p:nvSpPr>
-          <p:cNvPr id="82" name="Text 80"/>
+          <p:cNvPr id="85" name="Text 83"/>
           <p:cNvSpPr/>
           <p:nvPr/>
         </p:nvSpPr>
@@ -7839,7 +7764,7 @@
       </p:sp>
       <p:sp>
         <p:nvSpPr>
-          <p:cNvPr id="83" name="Text 81"/>
+          <p:cNvPr id="86" name="Text 84"/>
           <p:cNvSpPr/>
           <p:nvPr/>
         </p:nvSpPr>
@@ -11903,7 +11828,7 @@
                 <a:ea typeface="Georgia" pitchFamily="34" charset="-122"/>
                 <a:cs typeface="Georgia" pitchFamily="34" charset="-120"/>
               </a:rPr>
-              <a:t>73%</a:t>
+              <a:t>92%</a:t>
             </a:r>
             <a:endParaRPr lang="en-US" sz="15000" dirty="0"/>
           </a:p>
@@ -11942,7 +11867,7 @@
                 <a:ea typeface="Calibri" pitchFamily="34" charset="-122"/>
                 <a:cs typeface="Calibri" pitchFamily="34" charset="-120"/>
               </a:rPr>
-              <a:t>of pre-retirees say their biggest fears</a:t>
+              <a:t>of retirees say having a sense of purpose</a:t>
             </a:r>
             <a:endParaRPr lang="en-US" sz="1500" dirty="0"/>
           </a:p>
@@ -11959,7 +11884,7 @@
                 <a:ea typeface="Calibri" pitchFamily="34" charset="-122"/>
                 <a:cs typeface="Calibri" pitchFamily="34" charset="-120"/>
               </a:rPr>
-              <a:t>about retirement are NOT financial.</a:t>
+              <a:t>is essential to a successful retirement.</a:t>
             </a:r>
             <a:endParaRPr lang="en-US" sz="1500" dirty="0"/>
           </a:p>
@@ -11973,8 +11898,8 @@
         </p:nvSpPr>
         <p:spPr>
           <a:xfrm>
-            <a:off x="6400800" y="2743200"/>
-            <a:ext cx="5029200" cy="960120"/>
+            <a:off x="6400800" y="2697480"/>
+            <a:ext cx="5029200" cy="1078992"/>
           </a:xfrm>
           <a:prstGeom prst="rect">
             <a:avLst/>
@@ -11998,8 +11923,8 @@
         </p:nvSpPr>
         <p:spPr>
           <a:xfrm>
-            <a:off x="6400800" y="2743200"/>
-            <a:ext cx="73152" cy="960120"/>
+            <a:off x="6400800" y="2697480"/>
+            <a:ext cx="73152" cy="1078992"/>
           </a:xfrm>
           <a:prstGeom prst="rect">
             <a:avLst/>
@@ -12018,7 +11943,7 @@
         </p:nvSpPr>
         <p:spPr>
           <a:xfrm>
-            <a:off x="6629400" y="2852928"/>
+            <a:off x="6629400" y="2807208"/>
             <a:ext cx="914400" cy="777240"/>
           </a:xfrm>
           <a:prstGeom prst="rect">
@@ -12035,7 +11960,7 @@
               <a:buNone/>
             </a:pPr>
             <a:r>
-              <a:rPr lang="en-US" sz="3600" b="1" dirty="0">
+              <a:rPr lang="en-US" sz="3200" b="1" dirty="0">
                 <a:solidFill>
                   <a:srgbClr val="FFFFFF"/>
                 </a:solidFill>
@@ -12045,7 +11970,7 @@
               </a:rPr>
               <a:t>1/3</a:t>
             </a:r>
-            <a:endParaRPr lang="en-US" sz="3600" dirty="0"/>
+            <a:endParaRPr lang="en-US" sz="3200" dirty="0"/>
           </a:p>
         </p:txBody>
       </p:sp>
@@ -12057,24 +11982,24 @@
         </p:nvSpPr>
         <p:spPr>
           <a:xfrm>
-            <a:off x="7680960" y="2852928"/>
-            <a:ext cx="3657600" cy="365760"/>
-          </a:xfrm>
-          <a:prstGeom prst="rect">
-            <a:avLst/>
-          </a:prstGeom>
-          <a:noFill/>
-          <a:ln/>
-        </p:spPr>
-        <p:txBody>
-          <a:bodyPr wrap="square" lIns="0" tIns="0" rIns="0" bIns="0" rtlCol="0" anchor="ctr"/>
-          <a:lstStyle/>
-          <a:p>
-            <a:pPr indent="0" marL="0">
-              <a:buNone/>
-            </a:pPr>
-            <a:r>
-              <a:rPr lang="en-US" sz="1600" b="1" dirty="0">
+            <a:off x="7680960" y="2788920"/>
+            <a:ext cx="3657600" cy="320040"/>
+          </a:xfrm>
+          <a:prstGeom prst="rect">
+            <a:avLst/>
+          </a:prstGeom>
+          <a:noFill/>
+          <a:ln/>
+        </p:spPr>
+        <p:txBody>
+          <a:bodyPr wrap="square" lIns="0" tIns="0" rIns="0" bIns="0" rtlCol="0" anchor="ctr"/>
+          <a:lstStyle/>
+          <a:p>
+            <a:pPr indent="0" marL="0">
+              <a:buNone/>
+            </a:pPr>
+            <a:r>
+              <a:rPr lang="en-US" sz="1500" b="1" dirty="0">
                 <a:solidFill>
                   <a:srgbClr val="FFFFFF"/>
                 </a:solidFill>
@@ -12084,7 +12009,7 @@
               </a:rPr>
               <a:t>Financial Security</a:t>
             </a:r>
-            <a:endParaRPr lang="en-US" sz="1600" dirty="0"/>
+            <a:endParaRPr lang="en-US" sz="1500" dirty="0"/>
           </a:p>
         </p:txBody>
       </p:sp>
@@ -12096,24 +12021,24 @@
         </p:nvSpPr>
         <p:spPr>
           <a:xfrm>
-            <a:off x="7680960" y="3218688"/>
-            <a:ext cx="3657600" cy="457200"/>
-          </a:xfrm>
-          <a:prstGeom prst="rect">
-            <a:avLst/>
-          </a:prstGeom>
-          <a:noFill/>
-          <a:ln/>
-        </p:spPr>
-        <p:txBody>
-          <a:bodyPr wrap="square" lIns="0" tIns="0" rIns="0" bIns="0" rtlCol="0" anchor="ctr"/>
-          <a:lstStyle/>
-          <a:p>
-            <a:pPr indent="0" marL="0">
-              <a:buNone/>
-            </a:pPr>
-            <a:r>
-              <a:rPr lang="en-US" sz="1100" i="1" dirty="0">
+            <a:off x="7680960" y="3081528"/>
+            <a:ext cx="3657600" cy="292608"/>
+          </a:xfrm>
+          <a:prstGeom prst="rect">
+            <a:avLst/>
+          </a:prstGeom>
+          <a:noFill/>
+          <a:ln/>
+        </p:spPr>
+        <p:txBody>
+          <a:bodyPr wrap="square" lIns="0" tIns="0" rIns="0" bIns="0" rtlCol="0" anchor="ctr"/>
+          <a:lstStyle/>
+          <a:p>
+            <a:pPr indent="0" marL="0">
+              <a:buNone/>
+            </a:pPr>
+            <a:r>
+              <a:rPr lang="en-US" sz="1050" i="1" dirty="0">
                 <a:solidFill>
                   <a:srgbClr val="9CA8C2"/>
                 </a:solidFill>
@@ -12121,22 +12046,61 @@
                 <a:ea typeface="Calibri" pitchFamily="34" charset="-122"/>
                 <a:cs typeface="Calibri" pitchFamily="34" charset="-120"/>
               </a:rPr>
-              <a:t>What planning software solves.</a:t>
-            </a:r>
-            <a:endParaRPr lang="en-US" sz="1100" dirty="0"/>
-          </a:p>
-        </p:txBody>
-      </p:sp>
-      <p:sp>
-        <p:nvSpPr>
-          <p:cNvPr id="13" name="Shape 11"/>
-          <p:cNvSpPr/>
-          <p:nvPr/>
-        </p:nvSpPr>
-        <p:spPr>
-          <a:xfrm>
-            <a:off x="6400800" y="3886200"/>
-            <a:ext cx="5029200" cy="960120"/>
+              <a:t>Income, taxes, withdrawals — what your software solves.</a:t>
+            </a:r>
+            <a:endParaRPr lang="en-US" sz="1050" dirty="0"/>
+          </a:p>
+        </p:txBody>
+      </p:sp>
+      <p:sp>
+        <p:nvSpPr>
+          <p:cNvPr id="13" name="Text 11"/>
+          <p:cNvSpPr/>
+          <p:nvPr/>
+        </p:nvSpPr>
+        <p:spPr>
+          <a:xfrm>
+            <a:off x="7680960" y="3410712"/>
+            <a:ext cx="3657600" cy="292608"/>
+          </a:xfrm>
+          <a:prstGeom prst="rect">
+            <a:avLst/>
+          </a:prstGeom>
+          <a:noFill/>
+          <a:ln/>
+        </p:spPr>
+        <p:txBody>
+          <a:bodyPr wrap="square" lIns="0" tIns="0" rIns="0" bIns="0" rtlCol="0" anchor="ctr"/>
+          <a:lstStyle/>
+          <a:p>
+            <a:pPr indent="0" marL="0">
+              <a:buNone/>
+            </a:pPr>
+            <a:r>
+              <a:rPr lang="en-US" sz="950" b="1" dirty="0">
+                <a:solidFill>
+                  <a:srgbClr val="2D7DD2"/>
+                </a:solidFill>
+                <a:latin typeface="Calibri" pitchFamily="34" charset="0"/>
+                <a:ea typeface="Calibri" pitchFamily="34" charset="-122"/>
+                <a:cs typeface="Calibri" pitchFamily="34" charset="-120"/>
+              </a:rPr>
+              <a:t>≈ $315K projected lifetime healthcare bill — Fidelity, 2024.</a:t>
+            </a:r>
+            <a:endParaRPr lang="en-US" sz="950" dirty="0"/>
+          </a:p>
+        </p:txBody>
+      </p:sp>
+      <p:sp>
+        <p:nvSpPr>
+          <p:cNvPr id="14" name="Shape 12"/>
+          <p:cNvSpPr/>
+          <p:nvPr/>
+        </p:nvSpPr>
+        <p:spPr>
+          <a:xfrm>
+            <a:off x="6400800" y="3904488"/>
+            <a:ext cx="5029200" cy="1078992"/>
           </a:xfrm>
           <a:prstGeom prst="rect">
             <a:avLst/>
@@ -12154,14 +12118,14 @@
       </p:sp>
       <p:sp>
         <p:nvSpPr>
-          <p:cNvPr id="14" name="Shape 12"/>
-          <p:cNvSpPr/>
-          <p:nvPr/>
-        </p:nvSpPr>
-        <p:spPr>
-          <a:xfrm>
-            <a:off x="6400800" y="3886200"/>
-            <a:ext cx="73152" cy="960120"/>
+          <p:cNvPr id="15" name="Shape 13"/>
+          <p:cNvSpPr/>
+          <p:nvPr/>
+        </p:nvSpPr>
+        <p:spPr>
+          <a:xfrm>
+            <a:off x="6400800" y="3904488"/>
+            <a:ext cx="73152" cy="1078992"/>
           </a:xfrm>
           <a:prstGeom prst="rect">
             <a:avLst/>
@@ -12174,13 +12138,13 @@
       </p:sp>
       <p:sp>
         <p:nvSpPr>
-          <p:cNvPr id="15" name="Text 13"/>
-          <p:cNvSpPr/>
-          <p:nvPr/>
-        </p:nvSpPr>
-        <p:spPr>
-          <a:xfrm>
-            <a:off x="6629400" y="3995928"/>
+          <p:cNvPr id="16" name="Text 14"/>
+          <p:cNvSpPr/>
+          <p:nvPr/>
+        </p:nvSpPr>
+        <p:spPr>
+          <a:xfrm>
+            <a:off x="6629400" y="4014216"/>
             <a:ext cx="914400" cy="777240"/>
           </a:xfrm>
           <a:prstGeom prst="rect">
@@ -12197,7 +12161,7 @@
               <a:buNone/>
             </a:pPr>
             <a:r>
-              <a:rPr lang="en-US" sz="3600" b="1" dirty="0">
+              <a:rPr lang="en-US" sz="3200" b="1" dirty="0">
                 <a:solidFill>
                   <a:srgbClr val="FFFFFF"/>
                 </a:solidFill>
@@ -12207,36 +12171,36 @@
               </a:rPr>
               <a:t>1/3</a:t>
             </a:r>
-            <a:endParaRPr lang="en-US" sz="3600" dirty="0"/>
-          </a:p>
-        </p:txBody>
-      </p:sp>
-      <p:sp>
-        <p:nvSpPr>
-          <p:cNvPr id="16" name="Text 14"/>
+            <a:endParaRPr lang="en-US" sz="3200" dirty="0"/>
+          </a:p>
+        </p:txBody>
+      </p:sp>
+      <p:sp>
+        <p:nvSpPr>
+          <p:cNvPr id="17" name="Text 15"/>
           <p:cNvSpPr/>
           <p:nvPr/>
         </p:nvSpPr>
         <p:spPr>
           <a:xfrm>
             <a:off x="7680960" y="3995928"/>
-            <a:ext cx="3657600" cy="365760"/>
-          </a:xfrm>
-          <a:prstGeom prst="rect">
-            <a:avLst/>
-          </a:prstGeom>
-          <a:noFill/>
-          <a:ln/>
-        </p:spPr>
-        <p:txBody>
-          <a:bodyPr wrap="square" lIns="0" tIns="0" rIns="0" bIns="0" rtlCol="0" anchor="ctr"/>
-          <a:lstStyle/>
-          <a:p>
-            <a:pPr indent="0" marL="0">
-              <a:buNone/>
-            </a:pPr>
-            <a:r>
-              <a:rPr lang="en-US" sz="1600" b="1" dirty="0">
+            <a:ext cx="3657600" cy="320040"/>
+          </a:xfrm>
+          <a:prstGeom prst="rect">
+            <a:avLst/>
+          </a:prstGeom>
+          <a:noFill/>
+          <a:ln/>
+        </p:spPr>
+        <p:txBody>
+          <a:bodyPr wrap="square" lIns="0" tIns="0" rIns="0" bIns="0" rtlCol="0" anchor="ctr"/>
+          <a:lstStyle/>
+          <a:p>
+            <a:pPr indent="0" marL="0">
+              <a:buNone/>
+            </a:pPr>
+            <a:r>
+              <a:rPr lang="en-US" sz="1500" b="1" dirty="0">
                 <a:solidFill>
                   <a:srgbClr val="FFFFFF"/>
                 </a:solidFill>
@@ -12246,36 +12210,36 @@
               </a:rPr>
               <a:t>Lifestyle &amp; Purpose</a:t>
             </a:r>
-            <a:endParaRPr lang="en-US" sz="1600" dirty="0"/>
-          </a:p>
-        </p:txBody>
-      </p:sp>
-      <p:sp>
-        <p:nvSpPr>
-          <p:cNvPr id="17" name="Text 15"/>
-          <p:cNvSpPr/>
-          <p:nvPr/>
-        </p:nvSpPr>
-        <p:spPr>
-          <a:xfrm>
-            <a:off x="7680960" y="4361688"/>
-            <a:ext cx="3657600" cy="457200"/>
-          </a:xfrm>
-          <a:prstGeom prst="rect">
-            <a:avLst/>
-          </a:prstGeom>
-          <a:noFill/>
-          <a:ln/>
-        </p:spPr>
-        <p:txBody>
-          <a:bodyPr wrap="square" lIns="0" tIns="0" rIns="0" bIns="0" rtlCol="0" anchor="ctr"/>
-          <a:lstStyle/>
-          <a:p>
-            <a:pPr indent="0" marL="0">
-              <a:buNone/>
-            </a:pPr>
-            <a:r>
-              <a:rPr lang="en-US" sz="1100" i="1" dirty="0">
+            <a:endParaRPr lang="en-US" sz="1500" dirty="0"/>
+          </a:p>
+        </p:txBody>
+      </p:sp>
+      <p:sp>
+        <p:nvSpPr>
+          <p:cNvPr id="18" name="Text 16"/>
+          <p:cNvSpPr/>
+          <p:nvPr/>
+        </p:nvSpPr>
+        <p:spPr>
+          <a:xfrm>
+            <a:off x="7680960" y="4288536"/>
+            <a:ext cx="3657600" cy="292608"/>
+          </a:xfrm>
+          <a:prstGeom prst="rect">
+            <a:avLst/>
+          </a:prstGeom>
+          <a:noFill/>
+          <a:ln/>
+        </p:spPr>
+        <p:txBody>
+          <a:bodyPr wrap="square" lIns="0" tIns="0" rIns="0" bIns="0" rtlCol="0" anchor="ctr"/>
+          <a:lstStyle/>
+          <a:p>
+            <a:pPr indent="0" marL="0">
+              <a:buNone/>
+            </a:pPr>
+            <a:r>
+              <a:rPr lang="en-US" sz="1050" i="1" dirty="0">
                 <a:solidFill>
                   <a:srgbClr val="9CA8C2"/>
                 </a:solidFill>
@@ -12283,22 +12247,61 @@
                 <a:ea typeface="Calibri" pitchFamily="34" charset="-122"/>
                 <a:cs typeface="Calibri" pitchFamily="34" charset="-120"/>
               </a:rPr>
-              <a:t>Where will I live, who will I be, how will I spend my time?</a:t>
-            </a:r>
-            <a:endParaRPr lang="en-US" sz="1100" dirty="0"/>
-          </a:p>
-        </p:txBody>
-      </p:sp>
-      <p:sp>
-        <p:nvSpPr>
-          <p:cNvPr id="18" name="Shape 16"/>
-          <p:cNvSpPr/>
-          <p:nvPr/>
-        </p:nvSpPr>
-        <p:spPr>
-          <a:xfrm>
-            <a:off x="6400800" y="5029200"/>
-            <a:ext cx="5029200" cy="960120"/>
+              <a:t>Where, who, and how clients spend their time.</a:t>
+            </a:r>
+            <a:endParaRPr lang="en-US" sz="1050" dirty="0"/>
+          </a:p>
+        </p:txBody>
+      </p:sp>
+      <p:sp>
+        <p:nvSpPr>
+          <p:cNvPr id="19" name="Text 17"/>
+          <p:cNvSpPr/>
+          <p:nvPr/>
+        </p:nvSpPr>
+        <p:spPr>
+          <a:xfrm>
+            <a:off x="7680960" y="4617720"/>
+            <a:ext cx="3657600" cy="292608"/>
+          </a:xfrm>
+          <a:prstGeom prst="rect">
+            <a:avLst/>
+          </a:prstGeom>
+          <a:noFill/>
+          <a:ln/>
+        </p:spPr>
+        <p:txBody>
+          <a:bodyPr wrap="square" lIns="0" tIns="0" rIns="0" bIns="0" rtlCol="0" anchor="ctr"/>
+          <a:lstStyle/>
+          <a:p>
+            <a:pPr indent="0" marL="0">
+              <a:buNone/>
+            </a:pPr>
+            <a:r>
+              <a:rPr lang="en-US" sz="950" b="1" dirty="0">
+                <a:solidFill>
+                  <a:srgbClr val="E6B55A"/>
+                </a:solidFill>
+                <a:latin typeface="Calibri" pitchFamily="34" charset="0"/>
+                <a:ea typeface="Calibri" pitchFamily="34" charset="-122"/>
+                <a:cs typeface="Calibri" pitchFamily="34" charset="-120"/>
+              </a:rPr>
+              <a:t>Strong purpose → 15% lower mortality — Psychological Science, 2014.</a:t>
+            </a:r>
+            <a:endParaRPr lang="en-US" sz="950" dirty="0"/>
+          </a:p>
+        </p:txBody>
+      </p:sp>
+      <p:sp>
+        <p:nvSpPr>
+          <p:cNvPr id="20" name="Shape 18"/>
+          <p:cNvSpPr/>
+          <p:nvPr/>
+        </p:nvSpPr>
+        <p:spPr>
+          <a:xfrm>
+            <a:off x="6400800" y="5111496"/>
+            <a:ext cx="5029200" cy="1078992"/>
           </a:xfrm>
           <a:prstGeom prst="rect">
             <a:avLst/>
@@ -12316,14 +12319,14 @@
       </p:sp>
       <p:sp>
         <p:nvSpPr>
-          <p:cNvPr id="19" name="Shape 17"/>
-          <p:cNvSpPr/>
-          <p:nvPr/>
-        </p:nvSpPr>
-        <p:spPr>
-          <a:xfrm>
-            <a:off x="6400800" y="5029200"/>
-            <a:ext cx="73152" cy="960120"/>
+          <p:cNvPr id="21" name="Shape 19"/>
+          <p:cNvSpPr/>
+          <p:nvPr/>
+        </p:nvSpPr>
+        <p:spPr>
+          <a:xfrm>
+            <a:off x="6400800" y="5111496"/>
+            <a:ext cx="73152" cy="1078992"/>
           </a:xfrm>
           <a:prstGeom prst="rect">
             <a:avLst/>
@@ -12336,13 +12339,13 @@
       </p:sp>
       <p:sp>
         <p:nvSpPr>
-          <p:cNvPr id="20" name="Text 18"/>
-          <p:cNvSpPr/>
-          <p:nvPr/>
-        </p:nvSpPr>
-        <p:spPr>
-          <a:xfrm>
-            <a:off x="6629400" y="5138928"/>
+          <p:cNvPr id="22" name="Text 20"/>
+          <p:cNvSpPr/>
+          <p:nvPr/>
+        </p:nvSpPr>
+        <p:spPr>
+          <a:xfrm>
+            <a:off x="6629400" y="5221224"/>
             <a:ext cx="914400" cy="777240"/>
           </a:xfrm>
           <a:prstGeom prst="rect">
@@ -12359,7 +12362,7 @@
               <a:buNone/>
             </a:pPr>
             <a:r>
-              <a:rPr lang="en-US" sz="3600" b="1" dirty="0">
+              <a:rPr lang="en-US" sz="3200" b="1" dirty="0">
                 <a:solidFill>
                   <a:srgbClr val="FFFFFF"/>
                 </a:solidFill>
@@ -12369,36 +12372,36 @@
               </a:rPr>
               <a:t>1/3</a:t>
             </a:r>
-            <a:endParaRPr lang="en-US" sz="3600" dirty="0"/>
-          </a:p>
-        </p:txBody>
-      </p:sp>
-      <p:sp>
-        <p:nvSpPr>
-          <p:cNvPr id="21" name="Text 19"/>
-          <p:cNvSpPr/>
-          <p:nvPr/>
-        </p:nvSpPr>
-        <p:spPr>
-          <a:xfrm>
-            <a:off x="7680960" y="5138928"/>
-            <a:ext cx="3657600" cy="365760"/>
-          </a:xfrm>
-          <a:prstGeom prst="rect">
-            <a:avLst/>
-          </a:prstGeom>
-          <a:noFill/>
-          <a:ln/>
-        </p:spPr>
-        <p:txBody>
-          <a:bodyPr wrap="square" lIns="0" tIns="0" rIns="0" bIns="0" rtlCol="0" anchor="ctr"/>
-          <a:lstStyle/>
-          <a:p>
-            <a:pPr indent="0" marL="0">
-              <a:buNone/>
-            </a:pPr>
-            <a:r>
-              <a:rPr lang="en-US" sz="1600" b="1" dirty="0">
+            <a:endParaRPr lang="en-US" sz="3200" dirty="0"/>
+          </a:p>
+        </p:txBody>
+      </p:sp>
+      <p:sp>
+        <p:nvSpPr>
+          <p:cNvPr id="23" name="Text 21"/>
+          <p:cNvSpPr/>
+          <p:nvPr/>
+        </p:nvSpPr>
+        <p:spPr>
+          <a:xfrm>
+            <a:off x="7680960" y="5202936"/>
+            <a:ext cx="3657600" cy="320040"/>
+          </a:xfrm>
+          <a:prstGeom prst="rect">
+            <a:avLst/>
+          </a:prstGeom>
+          <a:noFill/>
+          <a:ln/>
+        </p:spPr>
+        <p:txBody>
+          <a:bodyPr wrap="square" lIns="0" tIns="0" rIns="0" bIns="0" rtlCol="0" anchor="ctr"/>
+          <a:lstStyle/>
+          <a:p>
+            <a:pPr indent="0" marL="0">
+              <a:buNone/>
+            </a:pPr>
+            <a:r>
+              <a:rPr lang="en-US" sz="1500" b="1" dirty="0">
                 <a:solidFill>
                   <a:srgbClr val="FFFFFF"/>
                 </a:solidFill>
@@ -12408,36 +12411,36 @@
               </a:rPr>
               <a:t>Legacy &amp; Impact</a:t>
             </a:r>
-            <a:endParaRPr lang="en-US" sz="1600" dirty="0"/>
-          </a:p>
-        </p:txBody>
-      </p:sp>
-      <p:sp>
-        <p:nvSpPr>
-          <p:cNvPr id="22" name="Text 20"/>
-          <p:cNvSpPr/>
-          <p:nvPr/>
-        </p:nvSpPr>
-        <p:spPr>
-          <a:xfrm>
-            <a:off x="7680960" y="5504688"/>
-            <a:ext cx="3657600" cy="457200"/>
-          </a:xfrm>
-          <a:prstGeom prst="rect">
-            <a:avLst/>
-          </a:prstGeom>
-          <a:noFill/>
-          <a:ln/>
-        </p:spPr>
-        <p:txBody>
-          <a:bodyPr wrap="square" lIns="0" tIns="0" rIns="0" bIns="0" rtlCol="0" anchor="ctr"/>
-          <a:lstStyle/>
-          <a:p>
-            <a:pPr indent="0" marL="0">
-              <a:buNone/>
-            </a:pPr>
-            <a:r>
-              <a:rPr lang="en-US" sz="1100" i="1" dirty="0">
+            <a:endParaRPr lang="en-US" sz="1500" dirty="0"/>
+          </a:p>
+        </p:txBody>
+      </p:sp>
+      <p:sp>
+        <p:nvSpPr>
+          <p:cNvPr id="24" name="Text 22"/>
+          <p:cNvSpPr/>
+          <p:nvPr/>
+        </p:nvSpPr>
+        <p:spPr>
+          <a:xfrm>
+            <a:off x="7680960" y="5495544"/>
+            <a:ext cx="3657600" cy="292608"/>
+          </a:xfrm>
+          <a:prstGeom prst="rect">
+            <a:avLst/>
+          </a:prstGeom>
+          <a:noFill/>
+          <a:ln/>
+        </p:spPr>
+        <p:txBody>
+          <a:bodyPr wrap="square" lIns="0" tIns="0" rIns="0" bIns="0" rtlCol="0" anchor="ctr"/>
+          <a:lstStyle/>
+          <a:p>
+            <a:pPr indent="0" marL="0">
+              <a:buNone/>
+            </a:pPr>
+            <a:r>
+              <a:rPr lang="en-US" sz="1050" i="1" dirty="0">
                 <a:solidFill>
                   <a:srgbClr val="9CA8C2"/>
                 </a:solidFill>
@@ -12445,15 +12448,54 @@
                 <a:ea typeface="Calibri" pitchFamily="34" charset="-122"/>
                 <a:cs typeface="Calibri" pitchFamily="34" charset="-120"/>
               </a:rPr>
-              <a:t>How will I be remembered, what will I leave behind?</a:t>
-            </a:r>
-            <a:endParaRPr lang="en-US" sz="1100" dirty="0"/>
-          </a:p>
-        </p:txBody>
-      </p:sp>
-      <p:sp>
-        <p:nvSpPr>
-          <p:cNvPr id="23" name="Text 21"/>
+              <a:t>What clients leave behind — financial and personal.</a:t>
+            </a:r>
+            <a:endParaRPr lang="en-US" sz="1050" dirty="0"/>
+          </a:p>
+        </p:txBody>
+      </p:sp>
+      <p:sp>
+        <p:nvSpPr>
+          <p:cNvPr id="25" name="Text 23"/>
+          <p:cNvSpPr/>
+          <p:nvPr/>
+        </p:nvSpPr>
+        <p:spPr>
+          <a:xfrm>
+            <a:off x="7680960" y="5824728"/>
+            <a:ext cx="3657600" cy="292608"/>
+          </a:xfrm>
+          <a:prstGeom prst="rect">
+            <a:avLst/>
+          </a:prstGeom>
+          <a:noFill/>
+          <a:ln/>
+        </p:spPr>
+        <p:txBody>
+          <a:bodyPr wrap="square" lIns="0" tIns="0" rIns="0" bIns="0" rtlCol="0" anchor="ctr"/>
+          <a:lstStyle/>
+          <a:p>
+            <a:pPr indent="0" marL="0">
+              <a:buNone/>
+            </a:pPr>
+            <a:r>
+              <a:rPr lang="en-US" sz="950" b="1" dirty="0">
+                <a:solidFill>
+                  <a:srgbClr val="10B981"/>
+                </a:solidFill>
+                <a:latin typeface="Calibri" pitchFamily="34" charset="0"/>
+                <a:ea typeface="Calibri" pitchFamily="34" charset="-122"/>
+                <a:cs typeface="Calibri" pitchFamily="34" charset="-120"/>
+              </a:rPr>
+              <a:t>Only 46% of Americans 55+ have a will — Caring.com, 2024.</a:t>
+            </a:r>
+            <a:endParaRPr lang="en-US" sz="950" dirty="0"/>
+          </a:p>
+        </p:txBody>
+      </p:sp>
+      <p:sp>
+        <p:nvSpPr>
+          <p:cNvPr id="26" name="Text 24"/>
           <p:cNvSpPr/>
           <p:nvPr/>
         </p:nvSpPr>
@@ -12484,7 +12526,7 @@
                 <a:ea typeface="Calibri" pitchFamily="34" charset="-122"/>
                 <a:cs typeface="Calibri" pitchFamily="34" charset="-120"/>
               </a:rPr>
-              <a:t>Source: EBRI Retirement Confidence Survey; Age Wave / Edward Jones “Four Pillars of the New Retirement.”</a:t>
+              <a:t>Sources: Edward Jones / Age Wave, “Four Pillars of the New Retirement”; Fidelity Retiree Health Care Cost Estimate (2024); Hill &amp; Turiano, Psychological Science (2014); Caring.com Wills &amp; Estate Planning Study (2024).</a:t>
             </a:r>
             <a:endParaRPr lang="en-US" sz="900" dirty="0"/>
           </a:p>
@@ -12492,7 +12534,7 @@
       </p:sp>
       <p:sp>
         <p:nvSpPr>
-          <p:cNvPr id="24" name="Shape 22"/>
+          <p:cNvPr id="27" name="Shape 25"/>
           <p:cNvSpPr/>
           <p:nvPr/>
         </p:nvSpPr>
@@ -12515,7 +12557,7 @@
       </p:sp>
       <p:sp>
         <p:nvSpPr>
-          <p:cNvPr id="25" name="Text 23"/>
+          <p:cNvPr id="28" name="Text 26"/>
           <p:cNvSpPr/>
           <p:nvPr/>
         </p:nvSpPr>
@@ -12554,7 +12596,7 @@
       </p:sp>
       <p:sp>
         <p:nvSpPr>
-          <p:cNvPr id="26" name="Text 24"/>
+          <p:cNvPr id="29" name="Text 27"/>
           <p:cNvSpPr/>
           <p:nvPr/>
         </p:nvSpPr>
@@ -12693,24 +12735,24 @@
         </p:nvSpPr>
         <p:spPr>
           <a:xfrm>
-            <a:off x="548640" y="1965960"/>
-            <a:ext cx="10972800" cy="502920"/>
-          </a:xfrm>
-          <a:prstGeom prst="rect">
-            <a:avLst/>
-          </a:prstGeom>
-          <a:noFill/>
-          <a:ln/>
-        </p:spPr>
-        <p:txBody>
-          <a:bodyPr wrap="square" lIns="0" tIns="0" rIns="0" bIns="0" rtlCol="0" anchor="ctr"/>
-          <a:lstStyle/>
-          <a:p>
-            <a:pPr indent="0" marL="0">
-              <a:buNone/>
-            </a:pPr>
-            <a:r>
-              <a:rPr lang="en-US" sz="2200" i="1" dirty="0">
+            <a:off x="548640" y="1920240"/>
+            <a:ext cx="11091672" cy="868680"/>
+          </a:xfrm>
+          <a:prstGeom prst="rect">
+            <a:avLst/>
+          </a:prstGeom>
+          <a:noFill/>
+          <a:ln/>
+        </p:spPr>
+        <p:txBody>
+          <a:bodyPr wrap="square" lIns="0" tIns="0" rIns="0" bIns="0" rtlCol="0" anchor="ctr"/>
+          <a:lstStyle/>
+          <a:p>
+            <a:pPr indent="0" marL="0">
+              <a:buNone/>
+            </a:pPr>
+            <a:r>
+              <a:rPr lang="en-US" sz="3000" b="1" dirty="0">
                 <a:solidFill>
                   <a:srgbClr val="2A354A"/>
                 </a:solidFill>
@@ -12718,545 +12760,466 @@
                 <a:ea typeface="Georgia" pitchFamily="34" charset="-122"/>
                 <a:cs typeface="Georgia" pitchFamily="34" charset="-120"/>
               </a:rPr>
-              <a:t>The engagement layer for fiduciary advisors.</a:t>
-            </a:r>
-            <a:endParaRPr lang="en-US" sz="2200" dirty="0"/>
-          </a:p>
-        </p:txBody>
-      </p:sp>
-      <p:sp>
-        <p:nvSpPr>
-          <p:cNvPr id="5" name="Shape 2"/>
-          <p:cNvSpPr/>
-          <p:nvPr/>
-        </p:nvSpPr>
-        <p:spPr>
-          <a:xfrm>
-            <a:off x="548640" y="2606040"/>
-            <a:ext cx="3703320" cy="3657600"/>
+              <a:t>An always-on engagement layer for fiduciary advisors.</a:t>
+            </a:r>
+            <a:endParaRPr lang="en-US" sz="3000" dirty="0"/>
+          </a:p>
+        </p:txBody>
+      </p:sp>
+      <p:sp>
+        <p:nvSpPr>
+          <p:cNvPr id="5" name="Text 2"/>
+          <p:cNvSpPr/>
+          <p:nvPr/>
+        </p:nvSpPr>
+        <p:spPr>
+          <a:xfrm>
+            <a:off x="548640" y="2971800"/>
+            <a:ext cx="6035040" cy="1920240"/>
+          </a:xfrm>
+          <a:prstGeom prst="rect">
+            <a:avLst/>
+          </a:prstGeom>
+          <a:noFill/>
+          <a:ln/>
+        </p:spPr>
+        <p:txBody>
+          <a:bodyPr wrap="square" lIns="0" tIns="0" rIns="0" bIns="0" rtlCol="0" anchor="ctr"/>
+          <a:lstStyle/>
+          <a:p>
+            <a:pPr indent="0" marL="0">
+              <a:spcAft>
+                <a:spcPts val="600"/>
+              </a:spcAft>
+              <a:buNone/>
+            </a:pPr>
+            <a:r>
+              <a:rPr lang="en-US" sz="1500" dirty="0">
+                <a:solidFill>
+                  <a:srgbClr val="6B5E62"/>
+                </a:solidFill>
+                <a:latin typeface="Calibri" pitchFamily="34" charset="0"/>
+                <a:ea typeface="Calibri" pitchFamily="34" charset="-122"/>
+                <a:cs typeface="Calibri" pitchFamily="34" charset="-120"/>
+              </a:rPr>
+              <a:t>RetireMore sits </a:t>
+            </a:r>
+            <a:pPr indent="0" marL="0">
+              <a:spcAft>
+                <a:spcPts val="600"/>
+              </a:spcAft>
+              <a:buNone/>
+            </a:pPr>
+            <a:r>
+              <a:rPr lang="en-US" sz="1500" b="1" dirty="0">
+                <a:solidFill>
+                  <a:srgbClr val="2A354A"/>
+                </a:solidFill>
+                <a:latin typeface="Calibri" pitchFamily="34" charset="0"/>
+                <a:ea typeface="Calibri" pitchFamily="34" charset="-122"/>
+                <a:cs typeface="Calibri" pitchFamily="34" charset="-120"/>
+              </a:rPr>
+              <a:t>alongside</a:t>
+            </a:r>
+            <a:pPr indent="0" marL="0">
+              <a:spcAft>
+                <a:spcPts val="600"/>
+              </a:spcAft>
+              <a:buNone/>
+            </a:pPr>
+            <a:r>
+              <a:rPr lang="en-US" sz="1500" dirty="0">
+                <a:solidFill>
+                  <a:srgbClr val="6B5E62"/>
+                </a:solidFill>
+                <a:latin typeface="Calibri" pitchFamily="34" charset="0"/>
+                <a:ea typeface="Calibri" pitchFamily="34" charset="-122"/>
+                <a:cs typeface="Calibri" pitchFamily="34" charset="-120"/>
+              </a:rPr>
+              <a:t> the planning software you already use — eMoney, RightCapital, MoneyGuidePro — not in place of it. Your stack is built for the financial half of retirement. </a:t>
+            </a:r>
+            <a:pPr indent="0" marL="0">
+              <a:spcAft>
+                <a:spcPts val="600"/>
+              </a:spcAft>
+              <a:buNone/>
+            </a:pPr>
+            <a:r>
+              <a:rPr lang="en-US" sz="1500" b="1" dirty="0">
+                <a:solidFill>
+                  <a:srgbClr val="2A354A"/>
+                </a:solidFill>
+                <a:latin typeface="Calibri" pitchFamily="34" charset="0"/>
+                <a:ea typeface="Calibri" pitchFamily="34" charset="-122"/>
+                <a:cs typeface="Calibri" pitchFamily="34" charset="-120"/>
+              </a:rPr>
+              <a:t>We're built for the rest:</a:t>
+            </a:r>
+            <a:pPr indent="0" marL="0">
+              <a:spcAft>
+                <a:spcPts val="600"/>
+              </a:spcAft>
+              <a:buNone/>
+            </a:pPr>
+            <a:r>
+              <a:rPr lang="en-US" sz="1500" dirty="0">
+                <a:solidFill>
+                  <a:srgbClr val="6B5E62"/>
+                </a:solidFill>
+                <a:latin typeface="Calibri" pitchFamily="34" charset="0"/>
+                <a:ea typeface="Calibri" pitchFamily="34" charset="-122"/>
+                <a:cs typeface="Calibri" pitchFamily="34" charset="-120"/>
+              </a:rPr>
+              <a:t> where your clients will live, who they'll be when they stop working, what they'll leave behind, and what happens to their digital life.</a:t>
+            </a:r>
+            <a:endParaRPr lang="en-US" sz="1500" dirty="0"/>
+          </a:p>
+        </p:txBody>
+      </p:sp>
+      <p:sp>
+        <p:nvSpPr>
+          <p:cNvPr id="6" name="Text 3"/>
+          <p:cNvSpPr/>
+          <p:nvPr/>
+        </p:nvSpPr>
+        <p:spPr>
+          <a:xfrm>
+            <a:off x="548640" y="4983480"/>
+            <a:ext cx="6035040" cy="914400"/>
+          </a:xfrm>
+          <a:prstGeom prst="rect">
+            <a:avLst/>
+          </a:prstGeom>
+          <a:noFill/>
+          <a:ln/>
+        </p:spPr>
+        <p:txBody>
+          <a:bodyPr wrap="square" lIns="0" tIns="0" rIns="0" bIns="0" rtlCol="0" anchor="ctr"/>
+          <a:lstStyle/>
+          <a:p>
+            <a:pPr indent="0" marL="0">
+              <a:buNone/>
+            </a:pPr>
+            <a:r>
+              <a:rPr lang="en-US" sz="1400" i="1" dirty="0">
+                <a:solidFill>
+                  <a:srgbClr val="2A354A"/>
+                </a:solidFill>
+                <a:latin typeface="Calibri" pitchFamily="34" charset="0"/>
+                <a:ea typeface="Calibri" pitchFamily="34" charset="-122"/>
+                <a:cs typeface="Calibri" pitchFamily="34" charset="-120"/>
+              </a:rPr>
+              <a:t>It's the part of retirement your clients keep asking about — and the part nobody else has built for advisors yet.</a:t>
+            </a:r>
+            <a:endParaRPr lang="en-US" sz="1400" dirty="0"/>
+          </a:p>
+        </p:txBody>
+      </p:sp>
+      <p:sp>
+        <p:nvSpPr>
+          <p:cNvPr id="7" name="Shape 4"/>
+          <p:cNvSpPr/>
+          <p:nvPr/>
+        </p:nvSpPr>
+        <p:spPr>
+          <a:xfrm>
+            <a:off x="6858000" y="2788920"/>
+            <a:ext cx="4782312" cy="3337560"/>
           </a:xfrm>
           <a:prstGeom prst="rect">
             <a:avLst/>
           </a:prstGeom>
           <a:solidFill>
-            <a:srgbClr val="FFFFFF"/>
+            <a:srgbClr val="1F2A45"/>
           </a:solidFill>
+          <a:ln/>
+          <a:effectLst>
+            <a:outerShdw sx="100000" sy="100000" kx="0" ky="0" algn="bl" rotWithShape="0" blurRad="127000" dist="38100" dir="5400000">
+              <a:srgbClr val="000000">
+                <a:alpha val="18000"/>
+              </a:srgbClr>
+            </a:outerShdw>
+          </a:effectLst>
+        </p:spPr>
+      </p:sp>
+      <p:sp>
+        <p:nvSpPr>
+          <p:cNvPr id="8" name="Shape 5"/>
+          <p:cNvSpPr/>
+          <p:nvPr/>
+        </p:nvSpPr>
+        <p:spPr>
+          <a:xfrm>
+            <a:off x="6858000" y="2788920"/>
+            <a:ext cx="91440" cy="3337560"/>
+          </a:xfrm>
+          <a:prstGeom prst="rect">
+            <a:avLst/>
+          </a:prstGeom>
+          <a:solidFill>
+            <a:srgbClr val="C8973A"/>
+          </a:solidFill>
+          <a:ln/>
+        </p:spPr>
+      </p:sp>
+      <p:sp>
+        <p:nvSpPr>
+          <p:cNvPr id="9" name="Text 6"/>
+          <p:cNvSpPr/>
+          <p:nvPr/>
+        </p:nvSpPr>
+        <p:spPr>
+          <a:xfrm>
+            <a:off x="7132320" y="2834640"/>
+            <a:ext cx="640080" cy="822960"/>
+          </a:xfrm>
+          <a:prstGeom prst="rect">
+            <a:avLst/>
+          </a:prstGeom>
+          <a:noFill/>
+          <a:ln/>
+        </p:spPr>
+        <p:txBody>
+          <a:bodyPr wrap="square" lIns="0" tIns="0" rIns="0" bIns="0" rtlCol="0" anchor="ctr"/>
+          <a:lstStyle/>
+          <a:p>
+            <a:pPr indent="0" marL="0">
+              <a:buNone/>
+            </a:pPr>
+            <a:r>
+              <a:rPr lang="en-US" sz="8000" b="1" dirty="0">
+                <a:solidFill>
+                  <a:srgbClr val="C8973A"/>
+                </a:solidFill>
+                <a:latin typeface="Georgia" pitchFamily="34" charset="0"/>
+                <a:ea typeface="Georgia" pitchFamily="34" charset="-122"/>
+                <a:cs typeface="Georgia" pitchFamily="34" charset="-120"/>
+              </a:rPr>
+              <a:t>“</a:t>
+            </a:r>
+            <a:endParaRPr lang="en-US" sz="8000" dirty="0"/>
+          </a:p>
+        </p:txBody>
+      </p:sp>
+      <p:sp>
+        <p:nvSpPr>
+          <p:cNvPr id="10" name="Text 7"/>
+          <p:cNvSpPr/>
+          <p:nvPr/>
+        </p:nvSpPr>
+        <p:spPr>
+          <a:xfrm>
+            <a:off x="7269480" y="3566160"/>
+            <a:ext cx="4142232" cy="1691640"/>
+          </a:xfrm>
+          <a:prstGeom prst="rect">
+            <a:avLst/>
+          </a:prstGeom>
+          <a:noFill/>
+          <a:ln/>
+        </p:spPr>
+        <p:txBody>
+          <a:bodyPr wrap="square" lIns="0" tIns="0" rIns="0" bIns="0" rtlCol="0" anchor="ctr"/>
+          <a:lstStyle/>
+          <a:p>
+            <a:pPr indent="0" marL="0">
+              <a:buNone/>
+            </a:pPr>
+            <a:r>
+              <a:rPr lang="en-US" sz="1600" i="1" dirty="0">
+                <a:solidFill>
+                  <a:srgbClr val="FFFFFF"/>
+                </a:solidFill>
+                <a:latin typeface="Georgia" pitchFamily="34" charset="0"/>
+                <a:ea typeface="Georgia" pitchFamily="34" charset="-122"/>
+                <a:cs typeface="Georgia" pitchFamily="34" charset="-120"/>
+              </a:rPr>
+              <a:t>The strongest predictors of health and happiness in later life are the quality of your relationships and your sense of meaning. Not your net worth. Not your asset allocation.</a:t>
+            </a:r>
+            <a:endParaRPr lang="en-US" sz="1600" dirty="0"/>
+          </a:p>
+        </p:txBody>
+      </p:sp>
+      <p:sp>
+        <p:nvSpPr>
+          <p:cNvPr id="11" name="Shape 8"/>
+          <p:cNvSpPr/>
+          <p:nvPr/>
+        </p:nvSpPr>
+        <p:spPr>
+          <a:xfrm>
+            <a:off x="7269480" y="5330952"/>
+            <a:ext cx="548640" cy="0"/>
+          </a:xfrm>
+          <a:prstGeom prst="line">
+            <a:avLst/>
+          </a:prstGeom>
+          <a:noFill/>
+          <a:ln w="25400">
+            <a:solidFill>
+              <a:srgbClr val="C8973A"/>
+            </a:solidFill>
+            <a:prstDash val="solid"/>
+          </a:ln>
+        </p:spPr>
+      </p:sp>
+      <p:sp>
+        <p:nvSpPr>
+          <p:cNvPr id="12" name="Text 9"/>
+          <p:cNvSpPr/>
+          <p:nvPr/>
+        </p:nvSpPr>
+        <p:spPr>
+          <a:xfrm>
+            <a:off x="7269480" y="5394960"/>
+            <a:ext cx="4142232" cy="256032"/>
+          </a:xfrm>
+          <a:prstGeom prst="rect">
+            <a:avLst/>
+          </a:prstGeom>
+          <a:noFill/>
+          <a:ln/>
+        </p:spPr>
+        <p:txBody>
+          <a:bodyPr wrap="square" lIns="0" tIns="0" rIns="0" bIns="0" rtlCol="0" anchor="ctr"/>
+          <a:lstStyle/>
+          <a:p>
+            <a:pPr indent="0" marL="0">
+              <a:buNone/>
+            </a:pPr>
+            <a:r>
+              <a:rPr lang="en-US" sz="1200" b="1" dirty="0">
+                <a:solidFill>
+                  <a:srgbClr val="C8973A"/>
+                </a:solidFill>
+                <a:latin typeface="Calibri" pitchFamily="34" charset="0"/>
+                <a:ea typeface="Calibri" pitchFamily="34" charset="-122"/>
+                <a:cs typeface="Calibri" pitchFamily="34" charset="-120"/>
+              </a:rPr>
+              <a:t>Robert Waldinger, MD</a:t>
+            </a:r>
+            <a:endParaRPr lang="en-US" sz="1200" dirty="0"/>
+          </a:p>
+        </p:txBody>
+      </p:sp>
+      <p:sp>
+        <p:nvSpPr>
+          <p:cNvPr id="13" name="Text 10"/>
+          <p:cNvSpPr/>
+          <p:nvPr/>
+        </p:nvSpPr>
+        <p:spPr>
+          <a:xfrm>
+            <a:off x="7269480" y="5650992"/>
+            <a:ext cx="4142232" cy="411480"/>
+          </a:xfrm>
+          <a:prstGeom prst="rect">
+            <a:avLst/>
+          </a:prstGeom>
+          <a:noFill/>
+          <a:ln/>
+        </p:spPr>
+        <p:txBody>
+          <a:bodyPr wrap="square" lIns="0" tIns="0" rIns="0" bIns="0" rtlCol="0" anchor="ctr"/>
+          <a:lstStyle/>
+          <a:p>
+            <a:pPr indent="0" marL="0">
+              <a:buNone/>
+            </a:pPr>
+            <a:r>
+              <a:rPr lang="en-US" sz="1000" i="1" dirty="0">
+                <a:solidFill>
+                  <a:srgbClr val="9CA8C2"/>
+                </a:solidFill>
+                <a:latin typeface="Calibri" pitchFamily="34" charset="0"/>
+                <a:ea typeface="Calibri" pitchFamily="34" charset="-122"/>
+                <a:cs typeface="Calibri" pitchFamily="34" charset="-120"/>
+              </a:rPr>
+              <a:t>Director, Harvard Study of Adult Development — the longest-running study of adult life, since 1938.</a:t>
+            </a:r>
+            <a:endParaRPr lang="en-US" sz="1000" dirty="0"/>
+          </a:p>
+        </p:txBody>
+      </p:sp>
+      <p:sp>
+        <p:nvSpPr>
+          <p:cNvPr id="14" name="Text 11"/>
+          <p:cNvSpPr/>
+          <p:nvPr/>
+        </p:nvSpPr>
+        <p:spPr>
+          <a:xfrm>
+            <a:off x="548640" y="5989320"/>
+            <a:ext cx="10972800" cy="365760"/>
+          </a:xfrm>
+          <a:prstGeom prst="rect">
+            <a:avLst/>
+          </a:prstGeom>
+          <a:noFill/>
+          <a:ln/>
+        </p:spPr>
+        <p:txBody>
+          <a:bodyPr wrap="square" lIns="0" tIns="0" rIns="0" bIns="0" rtlCol="0" anchor="ctr"/>
+          <a:lstStyle/>
+          <a:p>
+            <a:pPr indent="0" marL="0">
+              <a:buNone/>
+            </a:pPr>
+            <a:r>
+              <a:rPr lang="en-US" sz="1400" i="1" dirty="0">
+                <a:solidFill>
+                  <a:srgbClr val="6B5E62"/>
+                </a:solidFill>
+                <a:latin typeface="Calibri" pitchFamily="34" charset="0"/>
+                <a:ea typeface="Calibri" pitchFamily="34" charset="-122"/>
+                <a:cs typeface="Calibri" pitchFamily="34" charset="-120"/>
+              </a:rPr>
+              <a:t>RetireMore answers the questions your software </a:t>
+            </a:r>
+            <a:pPr indent="0" marL="0">
+              <a:buNone/>
+            </a:pPr>
+            <a:r>
+              <a:rPr lang="en-US" sz="1400" b="1" i="1" dirty="0">
+                <a:solidFill>
+                  <a:srgbClr val="0B5394"/>
+                </a:solidFill>
+                <a:latin typeface="Calibri" pitchFamily="34" charset="0"/>
+                <a:ea typeface="Calibri" pitchFamily="34" charset="-122"/>
+                <a:cs typeface="Calibri" pitchFamily="34" charset="-120"/>
+              </a:rPr>
+              <a:t>was never built to ask.</a:t>
+            </a:r>
+            <a:endParaRPr lang="en-US" sz="1400" dirty="0"/>
+          </a:p>
+        </p:txBody>
+      </p:sp>
+      <p:sp>
+        <p:nvSpPr>
+          <p:cNvPr id="15" name="Shape 12"/>
+          <p:cNvSpPr/>
+          <p:nvPr/>
+        </p:nvSpPr>
+        <p:spPr>
+          <a:xfrm>
+            <a:off x="548640" y="6446520"/>
+            <a:ext cx="11091672" cy="0"/>
+          </a:xfrm>
+          <a:prstGeom prst="line">
+            <a:avLst/>
+          </a:prstGeom>
+          <a:noFill/>
           <a:ln w="9525">
             <a:solidFill>
               <a:srgbClr val="E5E7EB"/>
             </a:solidFill>
             <a:prstDash val="solid"/>
           </a:ln>
-          <a:effectLst>
-            <a:outerShdw sx="100000" sy="100000" kx="0" ky="0" algn="bl" rotWithShape="0" blurRad="101600" dist="25400" dir="5400000">
-              <a:srgbClr val="000000">
-                <a:alpha val="6000"/>
-              </a:srgbClr>
-            </a:outerShdw>
-          </a:effectLst>
-        </p:spPr>
-      </p:sp>
-      <p:sp>
-        <p:nvSpPr>
-          <p:cNvPr id="6" name="Shape 3"/>
-          <p:cNvSpPr/>
-          <p:nvPr/>
-        </p:nvSpPr>
-        <p:spPr>
-          <a:xfrm>
-            <a:off x="548640" y="2606040"/>
-            <a:ext cx="3703320" cy="109728"/>
-          </a:xfrm>
-          <a:prstGeom prst="rect">
-            <a:avLst/>
-          </a:prstGeom>
-          <a:solidFill>
-            <a:srgbClr val="6B5E62"/>
-          </a:solidFill>
-          <a:ln/>
-        </p:spPr>
-      </p:sp>
-      <p:sp>
-        <p:nvSpPr>
-          <p:cNvPr id="7" name="Text 4"/>
-          <p:cNvSpPr/>
-          <p:nvPr/>
-        </p:nvSpPr>
-        <p:spPr>
-          <a:xfrm>
-            <a:off x="868680" y="2971800"/>
-            <a:ext cx="3063240" cy="274320"/>
-          </a:xfrm>
-          <a:prstGeom prst="rect">
-            <a:avLst/>
-          </a:prstGeom>
-          <a:noFill/>
-          <a:ln/>
-        </p:spPr>
-        <p:txBody>
-          <a:bodyPr wrap="square" lIns="0" tIns="0" rIns="0" bIns="0" rtlCol="0" anchor="ctr"/>
-          <a:lstStyle/>
-          <a:p>
-            <a:pPr indent="0" marL="0">
-              <a:buNone/>
-            </a:pPr>
-            <a:r>
-              <a:rPr lang="en-US" sz="1100" b="1" spc="600" kern="0" dirty="0">
-                <a:solidFill>
-                  <a:srgbClr val="6B5E62"/>
-                </a:solidFill>
-                <a:latin typeface="Calibri" pitchFamily="34" charset="0"/>
-                <a:ea typeface="Calibri" pitchFamily="34" charset="-122"/>
-                <a:cs typeface="Calibri" pitchFamily="34" charset="-120"/>
-              </a:rPr>
-              <a:t>WHAT IT'S NOT</a:t>
-            </a:r>
-            <a:endParaRPr lang="en-US" sz="1100" dirty="0"/>
-          </a:p>
-        </p:txBody>
-      </p:sp>
-      <p:sp>
-        <p:nvSpPr>
-          <p:cNvPr id="8" name="Text 5"/>
-          <p:cNvSpPr/>
-          <p:nvPr/>
-        </p:nvSpPr>
-        <p:spPr>
-          <a:xfrm>
-            <a:off x="868680" y="3383280"/>
-            <a:ext cx="3063240" cy="1097280"/>
-          </a:xfrm>
-          <a:prstGeom prst="rect">
-            <a:avLst/>
-          </a:prstGeom>
-          <a:noFill/>
-          <a:ln/>
-        </p:spPr>
-        <p:txBody>
-          <a:bodyPr wrap="square" lIns="0" tIns="0" rIns="0" bIns="0" rtlCol="0" anchor="ctr"/>
-          <a:lstStyle/>
-          <a:p>
-            <a:pPr indent="0" marL="0">
-              <a:buNone/>
-            </a:pPr>
-            <a:r>
-              <a:rPr lang="en-US" sz="2200" b="1" dirty="0">
-                <a:solidFill>
-                  <a:srgbClr val="2A354A"/>
-                </a:solidFill>
-                <a:latin typeface="Georgia" pitchFamily="34" charset="0"/>
-                <a:ea typeface="Georgia" pitchFamily="34" charset="-122"/>
-                <a:cs typeface="Georgia" pitchFamily="34" charset="-120"/>
-              </a:rPr>
-              <a:t>A planning software replacement.</a:t>
-            </a:r>
-            <a:endParaRPr lang="en-US" sz="2200" dirty="0"/>
-          </a:p>
-        </p:txBody>
-      </p:sp>
-      <p:sp>
-        <p:nvSpPr>
-          <p:cNvPr id="9" name="Text 6"/>
-          <p:cNvSpPr/>
-          <p:nvPr/>
-        </p:nvSpPr>
-        <p:spPr>
-          <a:xfrm>
-            <a:off x="868680" y="4617720"/>
-            <a:ext cx="3063240" cy="1463040"/>
-          </a:xfrm>
-          <a:prstGeom prst="rect">
-            <a:avLst/>
-          </a:prstGeom>
-          <a:noFill/>
-          <a:ln/>
-        </p:spPr>
-        <p:txBody>
-          <a:bodyPr wrap="square" lIns="0" tIns="0" rIns="0" bIns="0" rtlCol="0" anchor="ctr"/>
-          <a:lstStyle/>
-          <a:p>
-            <a:pPr indent="0" marL="0">
-              <a:buNone/>
-            </a:pPr>
-            <a:r>
-              <a:rPr lang="en-US" sz="1300" dirty="0">
-                <a:solidFill>
-                  <a:srgbClr val="6B5E62"/>
-                </a:solidFill>
-                <a:latin typeface="Calibri" pitchFamily="34" charset="0"/>
-                <a:ea typeface="Calibri" pitchFamily="34" charset="-122"/>
-                <a:cs typeface="Calibri" pitchFamily="34" charset="-120"/>
-              </a:rPr>
-              <a:t>Keep eMoney, RightCapital, MoneyGuidePro. RetireMore complements the planning you already do — it doesn't compete with it.</a:t>
-            </a:r>
-            <a:endParaRPr lang="en-US" sz="1300" dirty="0"/>
-          </a:p>
-        </p:txBody>
-      </p:sp>
-      <p:sp>
-        <p:nvSpPr>
-          <p:cNvPr id="10" name="Shape 7"/>
-          <p:cNvSpPr/>
-          <p:nvPr/>
-        </p:nvSpPr>
-        <p:spPr>
-          <a:xfrm>
-            <a:off x="4389120" y="2606040"/>
-            <a:ext cx="3703320" cy="3657600"/>
-          </a:xfrm>
-          <a:prstGeom prst="rect">
-            <a:avLst/>
-          </a:prstGeom>
-          <a:solidFill>
-            <a:srgbClr val="FFFFFF"/>
-          </a:solidFill>
-          <a:ln w="9525">
-            <a:solidFill>
-              <a:srgbClr val="E5E7EB"/>
-            </a:solidFill>
-            <a:prstDash val="solid"/>
-          </a:ln>
-          <a:effectLst>
-            <a:outerShdw sx="100000" sy="100000" kx="0" ky="0" algn="bl" rotWithShape="0" blurRad="101600" dist="25400" dir="5400000">
-              <a:srgbClr val="000000">
-                <a:alpha val="6000"/>
-              </a:srgbClr>
-            </a:outerShdw>
-          </a:effectLst>
-        </p:spPr>
-      </p:sp>
-      <p:sp>
-        <p:nvSpPr>
-          <p:cNvPr id="11" name="Shape 8"/>
-          <p:cNvSpPr/>
-          <p:nvPr/>
-        </p:nvSpPr>
-        <p:spPr>
-          <a:xfrm>
-            <a:off x="4389120" y="2606040"/>
-            <a:ext cx="3703320" cy="109728"/>
-          </a:xfrm>
-          <a:prstGeom prst="rect">
-            <a:avLst/>
-          </a:prstGeom>
-          <a:solidFill>
-            <a:srgbClr val="0B5394"/>
-          </a:solidFill>
-          <a:ln/>
-        </p:spPr>
-      </p:sp>
-      <p:sp>
-        <p:nvSpPr>
-          <p:cNvPr id="12" name="Text 9"/>
-          <p:cNvSpPr/>
-          <p:nvPr/>
-        </p:nvSpPr>
-        <p:spPr>
-          <a:xfrm>
-            <a:off x="4709160" y="2971800"/>
-            <a:ext cx="3063240" cy="274320"/>
-          </a:xfrm>
-          <a:prstGeom prst="rect">
-            <a:avLst/>
-          </a:prstGeom>
-          <a:noFill/>
-          <a:ln/>
-        </p:spPr>
-        <p:txBody>
-          <a:bodyPr wrap="square" lIns="0" tIns="0" rIns="0" bIns="0" rtlCol="0" anchor="ctr"/>
-          <a:lstStyle/>
-          <a:p>
-            <a:pPr indent="0" marL="0">
-              <a:buNone/>
-            </a:pPr>
-            <a:r>
-              <a:rPr lang="en-US" sz="1100" b="1" spc="600" kern="0" dirty="0">
-                <a:solidFill>
-                  <a:srgbClr val="0B5394"/>
-                </a:solidFill>
-                <a:latin typeface="Calibri" pitchFamily="34" charset="0"/>
-                <a:ea typeface="Calibri" pitchFamily="34" charset="-122"/>
-                <a:cs typeface="Calibri" pitchFamily="34" charset="-120"/>
-              </a:rPr>
-              <a:t>WHAT IT IS</a:t>
-            </a:r>
-            <a:endParaRPr lang="en-US" sz="1100" dirty="0"/>
-          </a:p>
-        </p:txBody>
-      </p:sp>
-      <p:sp>
-        <p:nvSpPr>
-          <p:cNvPr id="13" name="Text 10"/>
-          <p:cNvSpPr/>
-          <p:nvPr/>
-        </p:nvSpPr>
-        <p:spPr>
-          <a:xfrm>
-            <a:off x="4709160" y="3383280"/>
-            <a:ext cx="3063240" cy="1097280"/>
-          </a:xfrm>
-          <a:prstGeom prst="rect">
-            <a:avLst/>
-          </a:prstGeom>
-          <a:noFill/>
-          <a:ln/>
-        </p:spPr>
-        <p:txBody>
-          <a:bodyPr wrap="square" lIns="0" tIns="0" rIns="0" bIns="0" rtlCol="0" anchor="ctr"/>
-          <a:lstStyle/>
-          <a:p>
-            <a:pPr indent="0" marL="0">
-              <a:buNone/>
-            </a:pPr>
-            <a:r>
-              <a:rPr lang="en-US" sz="2200" b="1" dirty="0">
-                <a:solidFill>
-                  <a:srgbClr val="2A354A"/>
-                </a:solidFill>
-                <a:latin typeface="Georgia" pitchFamily="34" charset="0"/>
-                <a:ea typeface="Georgia" pitchFamily="34" charset="-122"/>
-                <a:cs typeface="Georgia" pitchFamily="34" charset="-120"/>
-              </a:rPr>
-              <a:t>An always-on engagement layer.</a:t>
-            </a:r>
-            <a:endParaRPr lang="en-US" sz="2200" dirty="0"/>
-          </a:p>
-        </p:txBody>
-      </p:sp>
-      <p:sp>
-        <p:nvSpPr>
-          <p:cNvPr id="14" name="Text 11"/>
-          <p:cNvSpPr/>
-          <p:nvPr/>
-        </p:nvSpPr>
-        <p:spPr>
-          <a:xfrm>
-            <a:off x="4709160" y="4617720"/>
-            <a:ext cx="3063240" cy="1463040"/>
-          </a:xfrm>
-          <a:prstGeom prst="rect">
-            <a:avLst/>
-          </a:prstGeom>
-          <a:noFill/>
-          <a:ln/>
-        </p:spPr>
-        <p:txBody>
-          <a:bodyPr wrap="square" lIns="0" tIns="0" rIns="0" bIns="0" rtlCol="0" anchor="ctr"/>
-          <a:lstStyle/>
-          <a:p>
-            <a:pPr indent="0" marL="0">
-              <a:buNone/>
-            </a:pPr>
-            <a:r>
-              <a:rPr lang="en-US" sz="1300" dirty="0">
-                <a:solidFill>
-                  <a:srgbClr val="6B5E62"/>
-                </a:solidFill>
-                <a:latin typeface="Calibri" pitchFamily="34" charset="0"/>
-                <a:ea typeface="Calibri" pitchFamily="34" charset="-122"/>
-                <a:cs typeface="Calibri" pitchFamily="34" charset="-120"/>
-              </a:rPr>
-              <a:t>12 retirement tools — financial, lifestyle, legacy — that your clients use between meetings to build a complete retirement plan, not just a financial one.</a:t>
-            </a:r>
-            <a:endParaRPr lang="en-US" sz="1300" dirty="0"/>
-          </a:p>
-        </p:txBody>
-      </p:sp>
-      <p:sp>
-        <p:nvSpPr>
-          <p:cNvPr id="15" name="Shape 12"/>
-          <p:cNvSpPr/>
-          <p:nvPr/>
-        </p:nvSpPr>
-        <p:spPr>
-          <a:xfrm>
-            <a:off x="8229600" y="2606040"/>
-            <a:ext cx="3703320" cy="3657600"/>
-          </a:xfrm>
-          <a:prstGeom prst="rect">
-            <a:avLst/>
-          </a:prstGeom>
-          <a:solidFill>
-            <a:srgbClr val="FFFFFF"/>
-          </a:solidFill>
-          <a:ln w="9525">
-            <a:solidFill>
-              <a:srgbClr val="E5E7EB"/>
-            </a:solidFill>
-            <a:prstDash val="solid"/>
-          </a:ln>
-          <a:effectLst>
-            <a:outerShdw sx="100000" sy="100000" kx="0" ky="0" algn="bl" rotWithShape="0" blurRad="101600" dist="25400" dir="5400000">
-              <a:srgbClr val="000000">
-                <a:alpha val="6000"/>
-              </a:srgbClr>
-            </a:outerShdw>
-          </a:effectLst>
-        </p:spPr>
-      </p:sp>
-      <p:sp>
-        <p:nvSpPr>
-          <p:cNvPr id="16" name="Shape 13"/>
-          <p:cNvSpPr/>
-          <p:nvPr/>
-        </p:nvSpPr>
-        <p:spPr>
-          <a:xfrm>
-            <a:off x="8229600" y="2606040"/>
-            <a:ext cx="3703320" cy="109728"/>
-          </a:xfrm>
-          <a:prstGeom prst="rect">
-            <a:avLst/>
-          </a:prstGeom>
-          <a:solidFill>
-            <a:srgbClr val="C8973A"/>
-          </a:solidFill>
-          <a:ln/>
-        </p:spPr>
-      </p:sp>
-      <p:sp>
-        <p:nvSpPr>
-          <p:cNvPr id="17" name="Text 14"/>
-          <p:cNvSpPr/>
-          <p:nvPr/>
-        </p:nvSpPr>
-        <p:spPr>
-          <a:xfrm>
-            <a:off x="8549640" y="2971800"/>
-            <a:ext cx="3063240" cy="274320"/>
-          </a:xfrm>
-          <a:prstGeom prst="rect">
-            <a:avLst/>
-          </a:prstGeom>
-          <a:noFill/>
-          <a:ln/>
-        </p:spPr>
-        <p:txBody>
-          <a:bodyPr wrap="square" lIns="0" tIns="0" rIns="0" bIns="0" rtlCol="0" anchor="ctr"/>
-          <a:lstStyle/>
-          <a:p>
-            <a:pPr indent="0" marL="0">
-              <a:buNone/>
-            </a:pPr>
-            <a:r>
-              <a:rPr lang="en-US" sz="1100" b="1" spc="600" kern="0" dirty="0">
-                <a:solidFill>
-                  <a:srgbClr val="C8973A"/>
-                </a:solidFill>
-                <a:latin typeface="Calibri" pitchFamily="34" charset="0"/>
-                <a:ea typeface="Calibri" pitchFamily="34" charset="-122"/>
-                <a:cs typeface="Calibri" pitchFamily="34" charset="-120"/>
-              </a:rPr>
-              <a:t>WHY IT MATTERS</a:t>
-            </a:r>
-            <a:endParaRPr lang="en-US" sz="1100" dirty="0"/>
-          </a:p>
-        </p:txBody>
-      </p:sp>
-      <p:sp>
-        <p:nvSpPr>
-          <p:cNvPr id="18" name="Text 15"/>
-          <p:cNvSpPr/>
-          <p:nvPr/>
-        </p:nvSpPr>
-        <p:spPr>
-          <a:xfrm>
-            <a:off x="8549640" y="3383280"/>
-            <a:ext cx="3063240" cy="1097280"/>
-          </a:xfrm>
-          <a:prstGeom prst="rect">
-            <a:avLst/>
-          </a:prstGeom>
-          <a:noFill/>
-          <a:ln/>
-        </p:spPr>
-        <p:txBody>
-          <a:bodyPr wrap="square" lIns="0" tIns="0" rIns="0" bIns="0" rtlCol="0" anchor="ctr"/>
-          <a:lstStyle/>
-          <a:p>
-            <a:pPr indent="0" marL="0">
-              <a:buNone/>
-            </a:pPr>
-            <a:r>
-              <a:rPr lang="en-US" sz="2200" b="1" dirty="0">
-                <a:solidFill>
-                  <a:srgbClr val="2A354A"/>
-                </a:solidFill>
-                <a:latin typeface="Georgia" pitchFamily="34" charset="0"/>
-                <a:ea typeface="Georgia" pitchFamily="34" charset="-122"/>
-                <a:cs typeface="Georgia" pitchFamily="34" charset="-120"/>
-              </a:rPr>
-              <a:t>The questions you can't bill for.</a:t>
-            </a:r>
-            <a:endParaRPr lang="en-US" sz="2200" dirty="0"/>
-          </a:p>
-        </p:txBody>
-      </p:sp>
-      <p:sp>
-        <p:nvSpPr>
-          <p:cNvPr id="19" name="Text 16"/>
-          <p:cNvSpPr/>
-          <p:nvPr/>
-        </p:nvSpPr>
-        <p:spPr>
-          <a:xfrm>
-            <a:off x="8549640" y="4617720"/>
-            <a:ext cx="3063240" cy="1463040"/>
-          </a:xfrm>
-          <a:prstGeom prst="rect">
-            <a:avLst/>
-          </a:prstGeom>
-          <a:noFill/>
-          <a:ln/>
-        </p:spPr>
-        <p:txBody>
-          <a:bodyPr wrap="square" lIns="0" tIns="0" rIns="0" bIns="0" rtlCol="0" anchor="ctr"/>
-          <a:lstStyle/>
-          <a:p>
-            <a:pPr indent="0" marL="0">
-              <a:buNone/>
-            </a:pPr>
-            <a:r>
-              <a:rPr lang="en-US" sz="1300" dirty="0">
-                <a:solidFill>
-                  <a:srgbClr val="6B5E62"/>
-                </a:solidFill>
-                <a:latin typeface="Calibri" pitchFamily="34" charset="0"/>
-                <a:ea typeface="Calibri" pitchFamily="34" charset="-122"/>
-                <a:cs typeface="Calibri" pitchFamily="34" charset="-120"/>
-              </a:rPr>
-              <a:t>Your clients want answers about identity, purpose, location, legacy, and digital life. RetireMore lets you answer them — and get credit for it.</a:t>
-            </a:r>
-            <a:endParaRPr lang="en-US" sz="1300" dirty="0"/>
-          </a:p>
-        </p:txBody>
-      </p:sp>
-      <p:sp>
-        <p:nvSpPr>
-          <p:cNvPr id="20" name="Shape 17"/>
-          <p:cNvSpPr/>
-          <p:nvPr/>
-        </p:nvSpPr>
-        <p:spPr>
-          <a:xfrm>
-            <a:off x="548640" y="6446520"/>
-            <a:ext cx="11091672" cy="0"/>
-          </a:xfrm>
-          <a:prstGeom prst="line">
-            <a:avLst/>
-          </a:prstGeom>
-          <a:noFill/>
-          <a:ln w="9525">
-            <a:solidFill>
-              <a:srgbClr val="E5E7EB"/>
-            </a:solidFill>
-            <a:prstDash val="solid"/>
-          </a:ln>
-        </p:spPr>
-      </p:sp>
-      <p:sp>
-        <p:nvSpPr>
-          <p:cNvPr id="21" name="Text 18"/>
+        </p:spPr>
+      </p:sp>
+      <p:sp>
+        <p:nvSpPr>
+          <p:cNvPr id="16" name="Text 13"/>
           <p:cNvSpPr/>
           <p:nvPr/>
         </p:nvSpPr>
@@ -13295,7 +13258,7 @@
       </p:sp>
       <p:sp>
         <p:nvSpPr>
-          <p:cNvPr id="22" name="Text 19"/>
+          <p:cNvPr id="17" name="Text 14"/>
           <p:cNvSpPr/>
           <p:nvPr/>
         </p:nvSpPr>

</xml_diff>

<commit_message>
Slide 3: tighten pillar stack so source line clears Legacy card
Reduce pillar step (1.32 → 1.25) and start (2.95 → 2.85), then move source
attribution down to y=6.78. Eliminates the visual collision between the
source line and the Legacy & Impact card above it.

Co-Authored-By: Claude Opus 4.7 (1M context) <noreply@anthropic.com>
</commit_message>
<xml_diff>
--- a/decks/RetireMore-CFP-Pitch-Deck.pptx
+++ b/decks/RetireMore-CFP-Pitch-Deck.pptx
@@ -11898,7 +11898,7 @@
         </p:nvSpPr>
         <p:spPr>
           <a:xfrm>
-            <a:off x="6400800" y="2697480"/>
+            <a:off x="6400800" y="2606040"/>
             <a:ext cx="5029200" cy="1078992"/>
           </a:xfrm>
           <a:prstGeom prst="rect">
@@ -11923,7 +11923,7 @@
         </p:nvSpPr>
         <p:spPr>
           <a:xfrm>
-            <a:off x="6400800" y="2697480"/>
+            <a:off x="6400800" y="2606040"/>
             <a:ext cx="73152" cy="1078992"/>
           </a:xfrm>
           <a:prstGeom prst="rect">
@@ -11943,7 +11943,7 @@
         </p:nvSpPr>
         <p:spPr>
           <a:xfrm>
-            <a:off x="6629400" y="2807208"/>
+            <a:off x="6629400" y="2715768"/>
             <a:ext cx="914400" cy="777240"/>
           </a:xfrm>
           <a:prstGeom prst="rect">
@@ -11982,7 +11982,7 @@
         </p:nvSpPr>
         <p:spPr>
           <a:xfrm>
-            <a:off x="7680960" y="2788920"/>
+            <a:off x="7680960" y="2697480"/>
             <a:ext cx="3657600" cy="320040"/>
           </a:xfrm>
           <a:prstGeom prst="rect">
@@ -12021,7 +12021,7 @@
         </p:nvSpPr>
         <p:spPr>
           <a:xfrm>
-            <a:off x="7680960" y="3081528"/>
+            <a:off x="7680960" y="2990088"/>
             <a:ext cx="3657600" cy="292608"/>
           </a:xfrm>
           <a:prstGeom prst="rect">
@@ -12060,7 +12060,7 @@
         </p:nvSpPr>
         <p:spPr>
           <a:xfrm>
-            <a:off x="7680960" y="3410712"/>
+            <a:off x="7680960" y="3319272"/>
             <a:ext cx="3657600" cy="292608"/>
           </a:xfrm>
           <a:prstGeom prst="rect">
@@ -12099,7 +12099,7 @@
         </p:nvSpPr>
         <p:spPr>
           <a:xfrm>
-            <a:off x="6400800" y="3904488"/>
+            <a:off x="6400800" y="3749040"/>
             <a:ext cx="5029200" cy="1078992"/>
           </a:xfrm>
           <a:prstGeom prst="rect">
@@ -12124,7 +12124,7 @@
         </p:nvSpPr>
         <p:spPr>
           <a:xfrm>
-            <a:off x="6400800" y="3904488"/>
+            <a:off x="6400800" y="3749040"/>
             <a:ext cx="73152" cy="1078992"/>
           </a:xfrm>
           <a:prstGeom prst="rect">
@@ -12144,7 +12144,7 @@
         </p:nvSpPr>
         <p:spPr>
           <a:xfrm>
-            <a:off x="6629400" y="4014216"/>
+            <a:off x="6629400" y="3858768"/>
             <a:ext cx="914400" cy="777240"/>
           </a:xfrm>
           <a:prstGeom prst="rect">
@@ -12183,7 +12183,7 @@
         </p:nvSpPr>
         <p:spPr>
           <a:xfrm>
-            <a:off x="7680960" y="3995928"/>
+            <a:off x="7680960" y="3840480"/>
             <a:ext cx="3657600" cy="320040"/>
           </a:xfrm>
           <a:prstGeom prst="rect">
@@ -12222,7 +12222,7 @@
         </p:nvSpPr>
         <p:spPr>
           <a:xfrm>
-            <a:off x="7680960" y="4288536"/>
+            <a:off x="7680960" y="4133088"/>
             <a:ext cx="3657600" cy="292608"/>
           </a:xfrm>
           <a:prstGeom prst="rect">
@@ -12261,7 +12261,7 @@
         </p:nvSpPr>
         <p:spPr>
           <a:xfrm>
-            <a:off x="7680960" y="4617720"/>
+            <a:off x="7680960" y="4462272"/>
             <a:ext cx="3657600" cy="292608"/>
           </a:xfrm>
           <a:prstGeom prst="rect">
@@ -12300,7 +12300,7 @@
         </p:nvSpPr>
         <p:spPr>
           <a:xfrm>
-            <a:off x="6400800" y="5111496"/>
+            <a:off x="6400800" y="4892040"/>
             <a:ext cx="5029200" cy="1078992"/>
           </a:xfrm>
           <a:prstGeom prst="rect">
@@ -12325,7 +12325,7 @@
         </p:nvSpPr>
         <p:spPr>
           <a:xfrm>
-            <a:off x="6400800" y="5111496"/>
+            <a:off x="6400800" y="4892040"/>
             <a:ext cx="73152" cy="1078992"/>
           </a:xfrm>
           <a:prstGeom prst="rect">
@@ -12345,7 +12345,7 @@
         </p:nvSpPr>
         <p:spPr>
           <a:xfrm>
-            <a:off x="6629400" y="5221224"/>
+            <a:off x="6629400" y="5001768"/>
             <a:ext cx="914400" cy="777240"/>
           </a:xfrm>
           <a:prstGeom prst="rect">
@@ -12384,7 +12384,7 @@
         </p:nvSpPr>
         <p:spPr>
           <a:xfrm>
-            <a:off x="7680960" y="5202936"/>
+            <a:off x="7680960" y="4983480"/>
             <a:ext cx="3657600" cy="320040"/>
           </a:xfrm>
           <a:prstGeom prst="rect">
@@ -12423,7 +12423,7 @@
         </p:nvSpPr>
         <p:spPr>
           <a:xfrm>
-            <a:off x="7680960" y="5495544"/>
+            <a:off x="7680960" y="5276088"/>
             <a:ext cx="3657600" cy="292608"/>
           </a:xfrm>
           <a:prstGeom prst="rect">
@@ -12462,7 +12462,7 @@
         </p:nvSpPr>
         <p:spPr>
           <a:xfrm>
-            <a:off x="7680960" y="5824728"/>
+            <a:off x="7680960" y="5605272"/>
             <a:ext cx="3657600" cy="292608"/>
           </a:xfrm>
           <a:prstGeom prst="rect">
@@ -12501,8 +12501,8 @@
         </p:nvSpPr>
         <p:spPr>
           <a:xfrm>
-            <a:off x="640080" y="6080760"/>
-            <a:ext cx="10972800" cy="274320"/>
+            <a:off x="640080" y="6199632"/>
+            <a:ext cx="10972800" cy="228600"/>
           </a:xfrm>
           <a:prstGeom prst="rect">
             <a:avLst/>

</xml_diff>